<commit_message>
implementation of logfile-generator in 'insight'
</commit_message>
<xml_diff>
--- a/Logfile_CustomerOrder_Generator/Logfile-Generator.pptx
+++ b/Logfile_CustomerOrder_Generator/Logfile-Generator.pptx
@@ -6,9 +6,7 @@
   </p:sldMasterIdLst>
   <p:sldIdLst>
     <p:sldId id="266" r:id="rId2"/>
-    <p:sldId id="257" r:id="rId3"/>
-    <p:sldId id="270" r:id="rId4"/>
-    <p:sldId id="263" r:id="rId5"/>
+    <p:sldId id="263" r:id="rId3"/>
   </p:sldIdLst>
   <p:sldSz cx="12192000" cy="6858000"/>
   <p:notesSz cx="6858000" cy="9144000"/>
@@ -262,7 +260,7 @@
           <a:p>
             <a:fld id="{7E064887-1312-4A4A-8E43-383F23D240A8}" type="datetimeFigureOut">
               <a:rPr lang="de-DE" smtClean="0"/>
-              <a:t>07. Apr. 2026</a:t>
+              <a:t>24. Apr. 2026</a:t>
             </a:fld>
             <a:endParaRPr lang="de-DE"/>
           </a:p>
@@ -460,7 +458,7 @@
           <a:p>
             <a:fld id="{7E064887-1312-4A4A-8E43-383F23D240A8}" type="datetimeFigureOut">
               <a:rPr lang="de-DE" smtClean="0"/>
-              <a:t>07. Apr. 2026</a:t>
+              <a:t>24. Apr. 2026</a:t>
             </a:fld>
             <a:endParaRPr lang="de-DE"/>
           </a:p>
@@ -668,7 +666,7 @@
           <a:p>
             <a:fld id="{7E064887-1312-4A4A-8E43-383F23D240A8}" type="datetimeFigureOut">
               <a:rPr lang="de-DE" smtClean="0"/>
-              <a:t>07. Apr. 2026</a:t>
+              <a:t>24. Apr. 2026</a:t>
             </a:fld>
             <a:endParaRPr lang="de-DE"/>
           </a:p>
@@ -866,7 +864,7 @@
           <a:p>
             <a:fld id="{7E064887-1312-4A4A-8E43-383F23D240A8}" type="datetimeFigureOut">
               <a:rPr lang="de-DE" smtClean="0"/>
-              <a:t>07. Apr. 2026</a:t>
+              <a:t>24. Apr. 2026</a:t>
             </a:fld>
             <a:endParaRPr lang="de-DE"/>
           </a:p>
@@ -1141,7 +1139,7 @@
           <a:p>
             <a:fld id="{7E064887-1312-4A4A-8E43-383F23D240A8}" type="datetimeFigureOut">
               <a:rPr lang="de-DE" smtClean="0"/>
-              <a:t>07. Apr. 2026</a:t>
+              <a:t>24. Apr. 2026</a:t>
             </a:fld>
             <a:endParaRPr lang="de-DE"/>
           </a:p>
@@ -1406,7 +1404,7 @@
           <a:p>
             <a:fld id="{7E064887-1312-4A4A-8E43-383F23D240A8}" type="datetimeFigureOut">
               <a:rPr lang="de-DE" smtClean="0"/>
-              <a:t>07. Apr. 2026</a:t>
+              <a:t>24. Apr. 2026</a:t>
             </a:fld>
             <a:endParaRPr lang="de-DE"/>
           </a:p>
@@ -1818,7 +1816,7 @@
           <a:p>
             <a:fld id="{7E064887-1312-4A4A-8E43-383F23D240A8}" type="datetimeFigureOut">
               <a:rPr lang="de-DE" smtClean="0"/>
-              <a:t>07. Apr. 2026</a:t>
+              <a:t>24. Apr. 2026</a:t>
             </a:fld>
             <a:endParaRPr lang="de-DE"/>
           </a:p>
@@ -1959,7 +1957,7 @@
           <a:p>
             <a:fld id="{7E064887-1312-4A4A-8E43-383F23D240A8}" type="datetimeFigureOut">
               <a:rPr lang="de-DE" smtClean="0"/>
-              <a:t>07. Apr. 2026</a:t>
+              <a:t>24. Apr. 2026</a:t>
             </a:fld>
             <a:endParaRPr lang="de-DE"/>
           </a:p>
@@ -2072,7 +2070,7 @@
           <a:p>
             <a:fld id="{7E064887-1312-4A4A-8E43-383F23D240A8}" type="datetimeFigureOut">
               <a:rPr lang="de-DE" smtClean="0"/>
-              <a:t>07. Apr. 2026</a:t>
+              <a:t>24. Apr. 2026</a:t>
             </a:fld>
             <a:endParaRPr lang="de-DE"/>
           </a:p>
@@ -2383,7 +2381,7 @@
           <a:p>
             <a:fld id="{7E064887-1312-4A4A-8E43-383F23D240A8}" type="datetimeFigureOut">
               <a:rPr lang="de-DE" smtClean="0"/>
-              <a:t>07. Apr. 2026</a:t>
+              <a:t>24. Apr. 2026</a:t>
             </a:fld>
             <a:endParaRPr lang="de-DE"/>
           </a:p>
@@ -2671,7 +2669,7 @@
           <a:p>
             <a:fld id="{7E064887-1312-4A4A-8E43-383F23D240A8}" type="datetimeFigureOut">
               <a:rPr lang="de-DE" smtClean="0"/>
-              <a:t>07. Apr. 2026</a:t>
+              <a:t>24. Apr. 2026</a:t>
             </a:fld>
             <a:endParaRPr lang="de-DE"/>
           </a:p>
@@ -2912,7 +2910,7 @@
           <a:p>
             <a:fld id="{7E064887-1312-4A4A-8E43-383F23D240A8}" type="datetimeFigureOut">
               <a:rPr lang="de-DE" smtClean="0"/>
-              <a:t>07. Apr. 2026</a:t>
+              <a:t>24. Apr. 2026</a:t>
             </a:fld>
             <a:endParaRPr lang="de-DE"/>
           </a:p>
@@ -3315,6 +3313,14 @@
 <file path=ppt/slides/slide1.xml><?xml version="1.0" encoding="utf-8"?>
 <p:sld xmlns:a="http://schemas.openxmlformats.org/drawingml/2006/main" xmlns:r="http://schemas.openxmlformats.org/officeDocument/2006/relationships" xmlns:p="http://schemas.openxmlformats.org/presentationml/2006/main">
   <p:cSld>
+    <p:bg>
+      <p:bgPr>
+        <a:solidFill>
+          <a:schemeClr val="tx1"/>
+        </a:solidFill>
+        <a:effectLst/>
+      </p:bgPr>
+    </p:bg>
     <p:spTree>
       <p:nvGrpSpPr>
         <p:cNvPr id="1" name=""/>
@@ -3331,10 +3337,10 @@
       </p:grpSpPr>
       <p:sp>
         <p:nvSpPr>
-          <p:cNvPr id="8" name="Textfeld 7">
-            <a:extLst>
-              <a:ext uri="{FF2B5EF4-FFF2-40B4-BE49-F238E27FC236}">
-                <a16:creationId xmlns:a16="http://schemas.microsoft.com/office/drawing/2014/main" id="{D086BD31-E1BC-F4DD-4E33-A5E391CC4652}"/>
+          <p:cNvPr id="10" name="Textfeld 9">
+            <a:extLst>
+              <a:ext uri="{FF2B5EF4-FFF2-40B4-BE49-F238E27FC236}">
+                <a16:creationId xmlns:a16="http://schemas.microsoft.com/office/drawing/2014/main" id="{6D4EFF53-F7EA-3888-22B7-6D62D44087C2}"/>
               </a:ext>
             </a:extLst>
           </p:cNvPr>
@@ -3343,118 +3349,15 @@
         </p:nvSpPr>
         <p:spPr>
           <a:xfrm>
-            <a:off x="1699444" y="903597"/>
-            <a:ext cx="8793109" cy="923330"/>
+            <a:off x="428622" y="366492"/>
+            <a:ext cx="11334750" cy="923330"/>
           </a:xfrm>
           <a:prstGeom prst="rect">
             <a:avLst/>
           </a:prstGeom>
-          <a:noFill/>
-        </p:spPr>
-        <p:txBody>
-          <a:bodyPr wrap="square" rtlCol="0">
-            <a:spAutoFit/>
-          </a:bodyPr>
-          <a:lstStyle/>
-          <a:p>
-            <a:pPr algn="ctr"/>
-            <a:r>
-              <a:rPr lang="de-DE" sz="5400" dirty="0">
-                <a:solidFill>
-                  <a:schemeClr val="bg1"/>
-                </a:solidFill>
-                <a:highlight>
-                  <a:srgbClr val="000080"/>
-                </a:highlight>
-              </a:rPr>
-              <a:t>„</a:t>
-            </a:r>
-            <a:r>
-              <a:rPr lang="de-DE" sz="5400" dirty="0" err="1">
-                <a:solidFill>
-                  <a:schemeClr val="bg1"/>
-                </a:solidFill>
-                <a:highlight>
-                  <a:srgbClr val="000080"/>
-                </a:highlight>
-              </a:rPr>
-              <a:t>Machine</a:t>
-            </a:r>
-            <a:r>
-              <a:rPr lang="de-DE" sz="5400" dirty="0">
-                <a:solidFill>
-                  <a:schemeClr val="bg1"/>
-                </a:solidFill>
-                <a:highlight>
-                  <a:srgbClr val="000080"/>
-                </a:highlight>
-              </a:rPr>
-              <a:t>-Log-Navigator“</a:t>
-            </a:r>
-          </a:p>
-        </p:txBody>
-      </p:sp>
-      <p:sp>
-        <p:nvSpPr>
-          <p:cNvPr id="9" name="Textfeld 8">
-            <a:extLst>
-              <a:ext uri="{FF2B5EF4-FFF2-40B4-BE49-F238E27FC236}">
-                <a16:creationId xmlns:a16="http://schemas.microsoft.com/office/drawing/2014/main" id="{D0DE56D0-5282-95A4-D998-16FFAD3F2473}"/>
-              </a:ext>
-            </a:extLst>
-          </p:cNvPr>
-          <p:cNvSpPr txBox="1"/>
-          <p:nvPr/>
-        </p:nvSpPr>
-        <p:spPr>
-          <a:xfrm>
-            <a:off x="2718756" y="1803126"/>
-            <a:ext cx="6754483" cy="261610"/>
-          </a:xfrm>
-          <a:prstGeom prst="rect">
-            <a:avLst/>
-          </a:prstGeom>
-          <a:noFill/>
-        </p:spPr>
-        <p:txBody>
-          <a:bodyPr wrap="square" rtlCol="0">
-            <a:spAutoFit/>
-          </a:bodyPr>
-          <a:lstStyle/>
-          <a:p>
-            <a:pPr algn="r"/>
-            <a:r>
-              <a:rPr lang="de-DE" sz="1100" b="1" i="1" dirty="0"/>
-              <a:t>DSI - Abschlußprojekt Team:   </a:t>
-            </a:r>
-            <a:r>
-              <a:rPr lang="de-DE" sz="1100" i="1" dirty="0"/>
-              <a:t>Michael Schipper, Mohamad Esber, Marco Michaelis | Date: April 2026</a:t>
-            </a:r>
-          </a:p>
-        </p:txBody>
-      </p:sp>
-      <p:sp>
-        <p:nvSpPr>
-          <p:cNvPr id="10" name="Textfeld 9">
-            <a:extLst>
-              <a:ext uri="{FF2B5EF4-FFF2-40B4-BE49-F238E27FC236}">
-                <a16:creationId xmlns:a16="http://schemas.microsoft.com/office/drawing/2014/main" id="{6D4EFF53-F7EA-3888-22B7-6D62D44087C2}"/>
-              </a:ext>
-            </a:extLst>
-          </p:cNvPr>
-          <p:cNvSpPr txBox="1"/>
-          <p:nvPr/>
-        </p:nvSpPr>
-        <p:spPr>
-          <a:xfrm>
-            <a:off x="428624" y="2144334"/>
-            <a:ext cx="11334750" cy="923330"/>
-          </a:xfrm>
-          <a:prstGeom prst="rect">
-            <a:avLst/>
-          </a:prstGeom>
-          <a:noFill/>
+          <a:solidFill>
+            <a:schemeClr val="bg1"/>
+          </a:solidFill>
         </p:spPr>
         <p:txBody>
           <a:bodyPr wrap="square" rtlCol="0">
@@ -3490,13 +3393,15 @@
         </p:nvSpPr>
         <p:spPr>
           <a:xfrm>
-            <a:off x="4479510" y="3379307"/>
+            <a:off x="4479510" y="2391155"/>
             <a:ext cx="3232974" cy="584775"/>
           </a:xfrm>
           <a:prstGeom prst="rect">
             <a:avLst/>
           </a:prstGeom>
-          <a:noFill/>
+          <a:solidFill>
+            <a:schemeClr val="bg1"/>
+          </a:solidFill>
         </p:spPr>
         <p:txBody>
           <a:bodyPr wrap="square" rtlCol="0">
@@ -3508,11 +3413,8 @@
             <a:r>
               <a:rPr lang="de-DE" sz="3200" b="1" dirty="0">
                 <a:solidFill>
-                  <a:schemeClr val="bg1"/>
+                  <a:srgbClr val="7030A0"/>
                 </a:solidFill>
-                <a:highlight>
-                  <a:srgbClr val="008000"/>
-                </a:highlight>
               </a:rPr>
               <a:t>Milestone-Ziel</a:t>
             </a:r>
@@ -3533,13 +3435,15 @@
         </p:nvSpPr>
         <p:spPr>
           <a:xfrm>
-            <a:off x="1514399" y="4224259"/>
-            <a:ext cx="9163202" cy="369332"/>
+            <a:off x="428622" y="3586950"/>
+            <a:ext cx="11334750" cy="369332"/>
           </a:xfrm>
           <a:prstGeom prst="rect">
             <a:avLst/>
           </a:prstGeom>
-          <a:noFill/>
+          <a:solidFill>
+            <a:schemeClr val="tx1"/>
+          </a:solidFill>
         </p:spPr>
         <p:txBody>
           <a:bodyPr wrap="square">
@@ -3547,8 +3451,13 @@
           </a:bodyPr>
           <a:lstStyle/>
           <a:p>
-            <a:r>
-              <a:rPr lang="de-DE" dirty="0"/>
+            <a:pPr algn="ctr"/>
+            <a:r>
+              <a:rPr lang="de-DE" b="1" dirty="0">
+                <a:solidFill>
+                  <a:schemeClr val="bg1"/>
+                </a:solidFill>
+              </a:rPr>
               <a:t>Jeder neue Durchlauf des Codes erzeugt ein neues Logfile mit neuen Daten-Konstellationen</a:t>
             </a:r>
           </a:p>
@@ -3568,13 +3477,15 @@
         </p:nvSpPr>
         <p:spPr>
           <a:xfrm>
-            <a:off x="1788335" y="4962923"/>
+            <a:off x="1788335" y="4325614"/>
             <a:ext cx="2872864" cy="646331"/>
           </a:xfrm>
           <a:prstGeom prst="rect">
             <a:avLst/>
           </a:prstGeom>
-          <a:noFill/>
+          <a:solidFill>
+            <a:schemeClr val="tx1"/>
+          </a:solidFill>
         </p:spPr>
         <p:txBody>
           <a:bodyPr wrap="square">
@@ -3584,14 +3495,22 @@
           <a:p>
             <a:pPr algn="r"/>
             <a:r>
-              <a:rPr lang="de-DE" dirty="0"/>
+              <a:rPr lang="de-DE" dirty="0">
+                <a:solidFill>
+                  <a:schemeClr val="bg1"/>
+                </a:solidFill>
+              </a:rPr>
               <a:t>Verwendung </a:t>
             </a:r>
           </a:p>
           <a:p>
             <a:pPr algn="r"/>
             <a:r>
-              <a:rPr lang="de-DE" dirty="0"/>
+              <a:rPr lang="de-DE" dirty="0">
+                <a:solidFill>
+                  <a:schemeClr val="bg1"/>
+                </a:solidFill>
+              </a:rPr>
               <a:t>für das Projekt</a:t>
             </a:r>
           </a:p>
@@ -3615,15 +3534,15 @@
         </p:nvCxnSpPr>
         <p:spPr>
           <a:xfrm>
-            <a:off x="6095997" y="3964082"/>
-            <a:ext cx="3" cy="260177"/>
+            <a:off x="6095997" y="2975930"/>
+            <a:ext cx="0" cy="611020"/>
           </a:xfrm>
           <a:prstGeom prst="straightConnector1">
             <a:avLst/>
           </a:prstGeom>
           <a:ln>
             <a:solidFill>
-              <a:schemeClr val="tx1"/>
+              <a:schemeClr val="bg1"/>
             </a:solidFill>
             <a:tailEnd type="triangle"/>
           </a:ln>
@@ -3660,15 +3579,15 @@
         </p:nvCxnSpPr>
         <p:spPr>
           <a:xfrm flipH="1">
-            <a:off x="4661199" y="4593591"/>
-            <a:ext cx="1434801" cy="475621"/>
+            <a:off x="4661199" y="3956282"/>
+            <a:ext cx="1434798" cy="475621"/>
           </a:xfrm>
           <a:prstGeom prst="straightConnector1">
             <a:avLst/>
           </a:prstGeom>
           <a:ln>
             <a:solidFill>
-              <a:schemeClr val="tx1"/>
+              <a:schemeClr val="bg1"/>
             </a:solidFill>
             <a:tailEnd type="triangle"/>
           </a:ln>
@@ -3705,15 +3624,15 @@
         </p:nvCxnSpPr>
         <p:spPr>
           <a:xfrm>
-            <a:off x="6096000" y="4593591"/>
-            <a:ext cx="1552309" cy="475619"/>
+            <a:off x="6095997" y="3956282"/>
+            <a:ext cx="1552312" cy="475619"/>
           </a:xfrm>
           <a:prstGeom prst="straightConnector1">
             <a:avLst/>
           </a:prstGeom>
           <a:ln>
             <a:solidFill>
-              <a:schemeClr val="tx1"/>
+              <a:schemeClr val="bg1"/>
             </a:solidFill>
             <a:tailEnd type="triangle"/>
           </a:ln>
@@ -3747,8 +3666,170 @@
         </p:nvSpPr>
         <p:spPr>
           <a:xfrm>
-            <a:off x="7648309" y="4962923"/>
+            <a:off x="7648309" y="4325614"/>
             <a:ext cx="2934016" cy="646331"/>
+          </a:xfrm>
+          <a:prstGeom prst="rect">
+            <a:avLst/>
+          </a:prstGeom>
+          <a:solidFill>
+            <a:schemeClr val="tx1"/>
+          </a:solidFill>
+        </p:spPr>
+        <p:txBody>
+          <a:bodyPr wrap="square">
+            <a:spAutoFit/>
+          </a:bodyPr>
+          <a:lstStyle/>
+          <a:p>
+            <a:r>
+              <a:rPr lang="de-DE" dirty="0">
+                <a:solidFill>
+                  <a:schemeClr val="bg1"/>
+                </a:solidFill>
+              </a:rPr>
+              <a:t>Verwendung für Entwickler zur Maschinenoptimierung</a:t>
+            </a:r>
+          </a:p>
+        </p:txBody>
+      </p:sp>
+      <p:sp>
+        <p:nvSpPr>
+          <p:cNvPr id="39" name="Textfeld 38">
+            <a:extLst>
+              <a:ext uri="{FF2B5EF4-FFF2-40B4-BE49-F238E27FC236}">
+                <a16:creationId xmlns:a16="http://schemas.microsoft.com/office/drawing/2014/main" id="{3CD9A18A-F69A-5E95-F189-DC6524DFA9CC}"/>
+              </a:ext>
+            </a:extLst>
+          </p:cNvPr>
+          <p:cNvSpPr txBox="1"/>
+          <p:nvPr/>
+        </p:nvSpPr>
+        <p:spPr>
+          <a:xfrm>
+            <a:off x="428622" y="1410804"/>
+            <a:ext cx="11334750" cy="461665"/>
+          </a:xfrm>
+          <a:prstGeom prst="rect">
+            <a:avLst/>
+          </a:prstGeom>
+          <a:solidFill>
+            <a:schemeClr val="tx1"/>
+          </a:solidFill>
+        </p:spPr>
+        <p:txBody>
+          <a:bodyPr wrap="square">
+            <a:spAutoFit/>
+          </a:bodyPr>
+          <a:lstStyle/>
+          <a:p>
+            <a:pPr algn="ctr"/>
+            <a:r>
+              <a:rPr lang="de-DE" sz="2400" b="1" dirty="0">
+                <a:solidFill>
+                  <a:schemeClr val="bg1"/>
+                </a:solidFill>
+              </a:rPr>
+              <a:t>Erzeugen von Real-Life-Szenarien</a:t>
+            </a:r>
+          </a:p>
+        </p:txBody>
+      </p:sp>
+      <p:pic>
+        <p:nvPicPr>
+          <p:cNvPr id="5" name="Grafik 4">
+            <a:extLst>
+              <a:ext uri="{FF2B5EF4-FFF2-40B4-BE49-F238E27FC236}">
+                <a16:creationId xmlns:a16="http://schemas.microsoft.com/office/drawing/2014/main" id="{8721A938-616A-DC62-3768-0941708BF5F7}"/>
+              </a:ext>
+            </a:extLst>
+          </p:cNvPr>
+          <p:cNvPicPr>
+            <a:picLocks noChangeAspect="1"/>
+          </p:cNvPicPr>
+          <p:nvPr/>
+        </p:nvPicPr>
+        <p:blipFill>
+          <a:blip r:embed="rId2"/>
+          <a:stretch>
+            <a:fillRect/>
+          </a:stretch>
+        </p:blipFill>
+        <p:spPr>
+          <a:xfrm>
+            <a:off x="4317210" y="5040698"/>
+            <a:ext cx="3813327" cy="1249656"/>
+          </a:xfrm>
+          <a:prstGeom prst="rect">
+            <a:avLst/>
+          </a:prstGeom>
+          <a:ln>
+            <a:noFill/>
+          </a:ln>
+          <a:effectLst>
+            <a:softEdge rad="112500"/>
+          </a:effectLst>
+        </p:spPr>
+      </p:pic>
+      <p:sp>
+        <p:nvSpPr>
+          <p:cNvPr id="6" name="Textfeld 5">
+            <a:extLst>
+              <a:ext uri="{FF2B5EF4-FFF2-40B4-BE49-F238E27FC236}">
+                <a16:creationId xmlns:a16="http://schemas.microsoft.com/office/drawing/2014/main" id="{0C30F8A2-C379-1F28-4962-2AD8EB87D1C1}"/>
+              </a:ext>
+            </a:extLst>
+          </p:cNvPr>
+          <p:cNvSpPr txBox="1"/>
+          <p:nvPr/>
+        </p:nvSpPr>
+        <p:spPr>
+          <a:xfrm rot="20303355">
+            <a:off x="4644099" y="5428079"/>
+            <a:ext cx="2421650" cy="369332"/>
+          </a:xfrm>
+          <a:prstGeom prst="rect">
+            <a:avLst/>
+          </a:prstGeom>
+          <a:solidFill>
+            <a:schemeClr val="tx1">
+              <a:alpha val="0"/>
+            </a:schemeClr>
+          </a:solidFill>
+        </p:spPr>
+        <p:txBody>
+          <a:bodyPr wrap="square" rtlCol="0">
+            <a:spAutoFit/>
+          </a:bodyPr>
+          <a:lstStyle/>
+          <a:p>
+            <a:r>
+              <a:rPr lang="de-DE" b="1" dirty="0">
+                <a:solidFill>
+                  <a:srgbClr val="0033CC"/>
+                </a:solidFill>
+              </a:rPr>
+              <a:t>ca. 5.000 Shipments</a:t>
+            </a:r>
+          </a:p>
+        </p:txBody>
+      </p:sp>
+      <p:sp>
+        <p:nvSpPr>
+          <p:cNvPr id="7" name="Textfeld 6">
+            <a:extLst>
+              <a:ext uri="{FF2B5EF4-FFF2-40B4-BE49-F238E27FC236}">
+                <a16:creationId xmlns:a16="http://schemas.microsoft.com/office/drawing/2014/main" id="{BD65FBBE-B198-6035-C3AC-BEC99156A116}"/>
+              </a:ext>
+            </a:extLst>
+          </p:cNvPr>
+          <p:cNvSpPr txBox="1"/>
+          <p:nvPr/>
+        </p:nvSpPr>
+        <p:spPr>
+          <a:xfrm rot="20303355">
+            <a:off x="5550520" y="5480860"/>
+            <a:ext cx="2075786" cy="369332"/>
           </a:xfrm>
           <a:prstGeom prst="rect">
             <a:avLst/>
@@ -3756,56 +3837,61 @@
           <a:noFill/>
         </p:spPr>
         <p:txBody>
+          <a:bodyPr wrap="square" rtlCol="0">
+            <a:spAutoFit/>
+          </a:bodyPr>
+          <a:lstStyle/>
+          <a:p>
+            <a:r>
+              <a:rPr lang="de-DE" b="1" dirty="0">
+                <a:solidFill>
+                  <a:srgbClr val="0033CC"/>
+                </a:solidFill>
+              </a:rPr>
+              <a:t>= ca. 15k log rows</a:t>
+            </a:r>
+          </a:p>
+        </p:txBody>
+      </p:sp>
+      <p:sp>
+        <p:nvSpPr>
+          <p:cNvPr id="11" name="Textfeld 10">
+            <a:extLst>
+              <a:ext uri="{FF2B5EF4-FFF2-40B4-BE49-F238E27FC236}">
+                <a16:creationId xmlns:a16="http://schemas.microsoft.com/office/drawing/2014/main" id="{EC64B14E-0975-0C4E-A433-AC9D22A8F69A}"/>
+              </a:ext>
+            </a:extLst>
+          </p:cNvPr>
+          <p:cNvSpPr txBox="1"/>
+          <p:nvPr/>
+        </p:nvSpPr>
+        <p:spPr>
+          <a:xfrm>
+            <a:off x="5306237" y="4763078"/>
+            <a:ext cx="1579520" cy="369332"/>
+          </a:xfrm>
+          <a:prstGeom prst="rect">
+            <a:avLst/>
+          </a:prstGeom>
+          <a:solidFill>
+            <a:schemeClr val="tx1"/>
+          </a:solidFill>
+        </p:spPr>
+        <p:txBody>
           <a:bodyPr wrap="square">
             <a:spAutoFit/>
           </a:bodyPr>
           <a:lstStyle/>
           <a:p>
-            <a:r>
-              <a:rPr lang="de-DE" dirty="0"/>
-              <a:t>Verwendung für Entwickler zur Maschinenoptimierung</a:t>
-            </a:r>
-          </a:p>
-        </p:txBody>
-      </p:sp>
-      <p:sp>
-        <p:nvSpPr>
-          <p:cNvPr id="39" name="Textfeld 38">
-            <a:extLst>
-              <a:ext uri="{FF2B5EF4-FFF2-40B4-BE49-F238E27FC236}">
-                <a16:creationId xmlns:a16="http://schemas.microsoft.com/office/drawing/2014/main" id="{3CD9A18A-F69A-5E95-F189-DC6524DFA9CC}"/>
-              </a:ext>
-            </a:extLst>
-          </p:cNvPr>
-          <p:cNvSpPr txBox="1"/>
-          <p:nvPr/>
-        </p:nvSpPr>
-        <p:spPr>
-          <a:xfrm>
-            <a:off x="4146506" y="2891029"/>
-            <a:ext cx="3898986" cy="369332"/>
-          </a:xfrm>
-          <a:prstGeom prst="rect">
-            <a:avLst/>
-          </a:prstGeom>
-          <a:noFill/>
-        </p:spPr>
-        <p:txBody>
-          <a:bodyPr wrap="square">
-            <a:spAutoFit/>
-          </a:bodyPr>
-          <a:lstStyle/>
-          <a:p>
             <a:pPr algn="ctr"/>
             <a:r>
-              <a:rPr lang="de-DE" dirty="0"/>
-              <a:t>Erzeugen von Real-Life-</a:t>
-            </a:r>
-            <a:r>
-              <a:rPr lang="de-DE" dirty="0" err="1"/>
-              <a:t>Scenarien</a:t>
-            </a:r>
-            <a:endParaRPr lang="de-DE" dirty="0"/>
+              <a:rPr lang="de-DE" dirty="0">
+                <a:solidFill>
+                  <a:schemeClr val="bg1"/>
+                </a:solidFill>
+              </a:rPr>
+              <a:t>Logfile</a:t>
+            </a:r>
           </a:p>
         </p:txBody>
       </p:sp>
@@ -3841,1017 +3927,56 @@
       </p:grpSpPr>
       <p:sp>
         <p:nvSpPr>
-          <p:cNvPr id="95" name="Rechteck 94">
-            <a:extLst>
-              <a:ext uri="{FF2B5EF4-FFF2-40B4-BE49-F238E27FC236}">
-                <a16:creationId xmlns:a16="http://schemas.microsoft.com/office/drawing/2014/main" id="{FC6CF400-FCED-1605-DCB5-9C13991A0F5A}"/>
-              </a:ext>
-            </a:extLst>
-          </p:cNvPr>
-          <p:cNvSpPr/>
-          <p:nvPr/>
-        </p:nvSpPr>
-        <p:spPr>
-          <a:xfrm>
-            <a:off x="4713740" y="1825248"/>
-            <a:ext cx="3593848" cy="1312379"/>
-          </a:xfrm>
-          <a:prstGeom prst="rect">
-            <a:avLst/>
-          </a:prstGeom>
+          <p:cNvPr id="2" name="Titel 1">
+            <a:extLst>
+              <a:ext uri="{FF2B5EF4-FFF2-40B4-BE49-F238E27FC236}">
+                <a16:creationId xmlns:a16="http://schemas.microsoft.com/office/drawing/2014/main" id="{AF5DA710-7168-EB00-79B6-37454B75FF5C}"/>
+              </a:ext>
+            </a:extLst>
+          </p:cNvPr>
+          <p:cNvSpPr>
+            <a:spLocks noGrp="1"/>
+          </p:cNvSpPr>
+          <p:nvPr>
+            <p:ph type="title"/>
+          </p:nvPr>
+        </p:nvSpPr>
+        <p:spPr>
+          <a:xfrm>
+            <a:off x="437071" y="277771"/>
+            <a:ext cx="11422419" cy="1325563"/>
+          </a:xfrm>
           <a:solidFill>
-            <a:schemeClr val="bg1">
-              <a:lumMod val="85000"/>
-              <a:alpha val="23000"/>
-            </a:schemeClr>
+            <a:schemeClr val="tx1"/>
           </a:solidFill>
-          <a:ln w="3175"/>
-        </p:spPr>
-        <p:style>
-          <a:lnRef idx="2">
-            <a:schemeClr val="accent1">
-              <a:shade val="15000"/>
-            </a:schemeClr>
-          </a:lnRef>
-          <a:fillRef idx="1">
-            <a:schemeClr val="accent1"/>
-          </a:fillRef>
-          <a:effectRef idx="0">
-            <a:schemeClr val="accent1"/>
-          </a:effectRef>
-          <a:fontRef idx="minor">
-            <a:schemeClr val="lt1"/>
-          </a:fontRef>
-        </p:style>
-        <p:txBody>
-          <a:bodyPr rtlCol="0" anchor="ctr"/>
+        </p:spPr>
+        <p:txBody>
+          <a:bodyPr/>
           <a:lstStyle/>
           <a:p>
             <a:pPr algn="ctr"/>
-            <a:endParaRPr lang="de-DE"/>
-          </a:p>
-        </p:txBody>
-      </p:sp>
-      <p:sp>
-        <p:nvSpPr>
-          <p:cNvPr id="11" name="Textfeld 10">
-            <a:extLst>
-              <a:ext uri="{FF2B5EF4-FFF2-40B4-BE49-F238E27FC236}">
-                <a16:creationId xmlns:a16="http://schemas.microsoft.com/office/drawing/2014/main" id="{06C2C856-C246-B5B3-1024-307E33157E90}"/>
-              </a:ext>
-            </a:extLst>
-          </p:cNvPr>
-          <p:cNvSpPr txBox="1"/>
-          <p:nvPr/>
-        </p:nvSpPr>
-        <p:spPr>
-          <a:xfrm>
-            <a:off x="9536556" y="1538213"/>
-            <a:ext cx="1329570" cy="400110"/>
-          </a:xfrm>
-          <a:prstGeom prst="rect">
-            <a:avLst/>
-          </a:prstGeom>
-          <a:noFill/>
-        </p:spPr>
-        <p:txBody>
-          <a:bodyPr wrap="square" rtlCol="0">
-            <a:spAutoFit/>
-          </a:bodyPr>
-          <a:lstStyle/>
-          <a:p>
-            <a:pPr algn="ctr"/>
-            <a:r>
-              <a:rPr lang="de-DE" sz="1000" i="1" dirty="0"/>
-              <a:t>Scanner liest Bestellbarcode-ID</a:t>
-            </a:r>
-          </a:p>
-        </p:txBody>
-      </p:sp>
-      <p:sp>
-        <p:nvSpPr>
-          <p:cNvPr id="19" name="Rechteck 18">
-            <a:extLst>
-              <a:ext uri="{FF2B5EF4-FFF2-40B4-BE49-F238E27FC236}">
-                <a16:creationId xmlns:a16="http://schemas.microsoft.com/office/drawing/2014/main" id="{BC7F62CA-78AB-FCFD-17C0-D5867A34FA10}"/>
-              </a:ext>
-            </a:extLst>
-          </p:cNvPr>
-          <p:cNvSpPr/>
-          <p:nvPr/>
-        </p:nvSpPr>
-        <p:spPr>
-          <a:xfrm rot="21295450">
-            <a:off x="489593" y="3892326"/>
-            <a:ext cx="10810431" cy="330687"/>
-          </a:xfrm>
-          <a:prstGeom prst="rect">
-            <a:avLst/>
-          </a:prstGeom>
-          <a:solidFill>
-            <a:srgbClr val="28201E"/>
-          </a:solidFill>
-          <a:ln>
-            <a:noFill/>
-          </a:ln>
-        </p:spPr>
-        <p:style>
-          <a:lnRef idx="2">
-            <a:schemeClr val="accent1">
-              <a:shade val="15000"/>
-            </a:schemeClr>
-          </a:lnRef>
-          <a:fillRef idx="1">
-            <a:schemeClr val="accent1"/>
-          </a:fillRef>
-          <a:effectRef idx="0">
-            <a:schemeClr val="accent1"/>
-          </a:effectRef>
-          <a:fontRef idx="minor">
-            <a:schemeClr val="lt1"/>
-          </a:fontRef>
-        </p:style>
-        <p:txBody>
-          <a:bodyPr rtlCol="0" anchor="ctr"/>
-          <a:lstStyle/>
-          <a:p>
-            <a:pPr algn="ctr"/>
-            <a:endParaRPr lang="de-DE"/>
-          </a:p>
-        </p:txBody>
-      </p:sp>
-      <p:sp>
-        <p:nvSpPr>
-          <p:cNvPr id="20" name="Rechteck 19">
-            <a:extLst>
-              <a:ext uri="{FF2B5EF4-FFF2-40B4-BE49-F238E27FC236}">
-                <a16:creationId xmlns:a16="http://schemas.microsoft.com/office/drawing/2014/main" id="{42723B3F-4EB5-DDD4-74B4-0F2259001371}"/>
-              </a:ext>
-            </a:extLst>
-          </p:cNvPr>
-          <p:cNvSpPr/>
-          <p:nvPr/>
-        </p:nvSpPr>
-        <p:spPr>
-          <a:xfrm rot="16200000">
-            <a:off x="1792023" y="4651420"/>
-            <a:ext cx="1117602" cy="330687"/>
-          </a:xfrm>
-          <a:prstGeom prst="rect">
-            <a:avLst/>
-          </a:prstGeom>
-          <a:solidFill>
-            <a:srgbClr val="28201E"/>
-          </a:solidFill>
-          <a:ln>
-            <a:noFill/>
-          </a:ln>
-        </p:spPr>
-        <p:style>
-          <a:lnRef idx="2">
-            <a:schemeClr val="accent1">
-              <a:shade val="15000"/>
-            </a:schemeClr>
-          </a:lnRef>
-          <a:fillRef idx="1">
-            <a:schemeClr val="accent1"/>
-          </a:fillRef>
-          <a:effectRef idx="0">
-            <a:schemeClr val="accent1"/>
-          </a:effectRef>
-          <a:fontRef idx="minor">
-            <a:schemeClr val="lt1"/>
-          </a:fontRef>
-        </p:style>
-        <p:txBody>
-          <a:bodyPr rtlCol="0" anchor="ctr"/>
-          <a:lstStyle/>
-          <a:p>
-            <a:pPr algn="ctr"/>
-            <a:endParaRPr lang="de-DE"/>
-          </a:p>
-        </p:txBody>
-      </p:sp>
-      <p:sp>
-        <p:nvSpPr>
-          <p:cNvPr id="21" name="Rechteck 20">
-            <a:extLst>
-              <a:ext uri="{FF2B5EF4-FFF2-40B4-BE49-F238E27FC236}">
-                <a16:creationId xmlns:a16="http://schemas.microsoft.com/office/drawing/2014/main" id="{18A04283-0B39-2252-3ACF-9E557F8ADC1E}"/>
-              </a:ext>
-            </a:extLst>
-          </p:cNvPr>
-          <p:cNvSpPr/>
-          <p:nvPr/>
-        </p:nvSpPr>
-        <p:spPr>
-          <a:xfrm>
-            <a:off x="1483511" y="5184063"/>
-            <a:ext cx="1853582" cy="942109"/>
-          </a:xfrm>
-          <a:prstGeom prst="rect">
-            <a:avLst/>
-          </a:prstGeom>
-          <a:solidFill>
-            <a:srgbClr val="0033CC"/>
-          </a:solidFill>
-          <a:ln w="34925">
-            <a:solidFill>
-              <a:schemeClr val="accent2"/>
-            </a:solidFill>
-          </a:ln>
-        </p:spPr>
-        <p:style>
-          <a:lnRef idx="2">
-            <a:schemeClr val="accent1">
-              <a:shade val="15000"/>
-            </a:schemeClr>
-          </a:lnRef>
-          <a:fillRef idx="1">
-            <a:schemeClr val="accent1"/>
-          </a:fillRef>
-          <a:effectRef idx="0">
-            <a:schemeClr val="accent1"/>
-          </a:effectRef>
-          <a:fontRef idx="minor">
-            <a:schemeClr val="lt1"/>
-          </a:fontRef>
-        </p:style>
-        <p:txBody>
-          <a:bodyPr rtlCol="0" anchor="ctr"/>
-          <a:lstStyle/>
-          <a:p>
-            <a:pPr algn="ctr"/>
-            <a:r>
-              <a:rPr lang="de-DE" dirty="0"/>
-              <a:t>Qualitätsstation</a:t>
-            </a:r>
-          </a:p>
-          <a:p>
-            <a:pPr algn="ctr"/>
-            <a:r>
-              <a:rPr lang="de-DE" dirty="0"/>
-              <a:t>Inhalt prüfen</a:t>
-            </a:r>
-          </a:p>
-        </p:txBody>
-      </p:sp>
-      <p:cxnSp>
-        <p:nvCxnSpPr>
-          <p:cNvPr id="27" name="Gerade Verbindung mit Pfeil 26">
-            <a:extLst>
-              <a:ext uri="{FF2B5EF4-FFF2-40B4-BE49-F238E27FC236}">
-                <a16:creationId xmlns:a16="http://schemas.microsoft.com/office/drawing/2014/main" id="{8A18EFB3-F57E-9178-152C-2939DCB86267}"/>
-              </a:ext>
-            </a:extLst>
-          </p:cNvPr>
-          <p:cNvCxnSpPr>
-            <a:cxnSpLocks/>
-          </p:cNvCxnSpPr>
-          <p:nvPr/>
-        </p:nvCxnSpPr>
-        <p:spPr>
-          <a:xfrm flipH="1">
-            <a:off x="1627610" y="4378740"/>
-            <a:ext cx="462620" cy="41379"/>
-          </a:xfrm>
-          <a:prstGeom prst="straightConnector1">
-            <a:avLst/>
-          </a:prstGeom>
-          <a:ln w="25400">
-            <a:solidFill>
-              <a:srgbClr val="00FF00"/>
-            </a:solidFill>
-            <a:prstDash val="sysDot"/>
-            <a:tailEnd type="triangle"/>
-          </a:ln>
-        </p:spPr>
-        <p:style>
-          <a:lnRef idx="2">
-            <a:schemeClr val="accent1"/>
-          </a:lnRef>
-          <a:fillRef idx="0">
-            <a:schemeClr val="accent1"/>
-          </a:fillRef>
-          <a:effectRef idx="1">
-            <a:schemeClr val="accent1"/>
-          </a:effectRef>
-          <a:fontRef idx="minor">
-            <a:schemeClr val="tx1"/>
-          </a:fontRef>
-        </p:style>
-      </p:cxnSp>
-      <p:cxnSp>
-        <p:nvCxnSpPr>
-          <p:cNvPr id="28" name="Gerade Verbindung mit Pfeil 27">
-            <a:extLst>
-              <a:ext uri="{FF2B5EF4-FFF2-40B4-BE49-F238E27FC236}">
-                <a16:creationId xmlns:a16="http://schemas.microsoft.com/office/drawing/2014/main" id="{F993F038-96B5-28AC-19DB-199A2015773E}"/>
-              </a:ext>
-            </a:extLst>
-          </p:cNvPr>
-          <p:cNvCxnSpPr>
-            <a:cxnSpLocks/>
-          </p:cNvCxnSpPr>
-          <p:nvPr/>
-        </p:nvCxnSpPr>
-        <p:spPr>
-          <a:xfrm>
-            <a:off x="2349805" y="4559630"/>
-            <a:ext cx="0" cy="514266"/>
-          </a:xfrm>
-          <a:prstGeom prst="straightConnector1">
-            <a:avLst/>
-          </a:prstGeom>
-          <a:ln w="25400">
-            <a:solidFill>
-              <a:srgbClr val="FF0000"/>
-            </a:solidFill>
-            <a:prstDash val="sysDot"/>
-            <a:tailEnd type="triangle"/>
-          </a:ln>
-        </p:spPr>
-        <p:style>
-          <a:lnRef idx="2">
-            <a:schemeClr val="accent1"/>
-          </a:lnRef>
-          <a:fillRef idx="0">
-            <a:schemeClr val="accent1"/>
-          </a:fillRef>
-          <a:effectRef idx="1">
-            <a:schemeClr val="accent1"/>
-          </a:effectRef>
-          <a:fontRef idx="minor">
-            <a:schemeClr val="tx1"/>
-          </a:fontRef>
-        </p:style>
-      </p:cxnSp>
-      <p:cxnSp>
-        <p:nvCxnSpPr>
-          <p:cNvPr id="31" name="Gerade Verbindung mit Pfeil 30">
-            <a:extLst>
-              <a:ext uri="{FF2B5EF4-FFF2-40B4-BE49-F238E27FC236}">
-                <a16:creationId xmlns:a16="http://schemas.microsoft.com/office/drawing/2014/main" id="{848B2089-9543-F77C-0072-AC9361385C6D}"/>
-              </a:ext>
-            </a:extLst>
-          </p:cNvPr>
-          <p:cNvCxnSpPr>
-            <a:cxnSpLocks/>
-          </p:cNvCxnSpPr>
-          <p:nvPr/>
-        </p:nvCxnSpPr>
-        <p:spPr>
-          <a:xfrm>
-            <a:off x="2354730" y="3774511"/>
-            <a:ext cx="0" cy="418224"/>
-          </a:xfrm>
-          <a:prstGeom prst="straightConnector1">
-            <a:avLst/>
-          </a:prstGeom>
-          <a:ln w="50800">
-            <a:solidFill>
-              <a:srgbClr val="FF0000"/>
-            </a:solidFill>
-            <a:tailEnd type="triangle"/>
-          </a:ln>
-        </p:spPr>
-        <p:style>
-          <a:lnRef idx="2">
-            <a:schemeClr val="accent1"/>
-          </a:lnRef>
-          <a:fillRef idx="0">
-            <a:schemeClr val="accent1"/>
-          </a:fillRef>
-          <a:effectRef idx="1">
-            <a:schemeClr val="accent1"/>
-          </a:effectRef>
-          <a:fontRef idx="minor">
-            <a:schemeClr val="tx1"/>
-          </a:fontRef>
-        </p:style>
-      </p:cxnSp>
-      <p:sp>
-        <p:nvSpPr>
-          <p:cNvPr id="33" name="Textfeld 32">
-            <a:extLst>
-              <a:ext uri="{FF2B5EF4-FFF2-40B4-BE49-F238E27FC236}">
-                <a16:creationId xmlns:a16="http://schemas.microsoft.com/office/drawing/2014/main" id="{06E67DA9-E8D0-3A40-DBB4-FC0438591899}"/>
-              </a:ext>
-            </a:extLst>
-          </p:cNvPr>
-          <p:cNvSpPr txBox="1"/>
-          <p:nvPr/>
-        </p:nvSpPr>
-        <p:spPr>
-          <a:xfrm>
-            <a:off x="1378311" y="2964391"/>
-            <a:ext cx="2115127" cy="861774"/>
-          </a:xfrm>
-          <a:prstGeom prst="rect">
-            <a:avLst/>
-          </a:prstGeom>
-          <a:noFill/>
-        </p:spPr>
-        <p:txBody>
-          <a:bodyPr wrap="square" rtlCol="0">
-            <a:spAutoFit/>
-          </a:bodyPr>
-          <a:lstStyle/>
-          <a:p>
-            <a:pPr algn="ctr"/>
-            <a:endParaRPr lang="de-DE" dirty="0"/>
-          </a:p>
-          <a:p>
-            <a:pPr algn="ctr"/>
-            <a:endParaRPr lang="de-DE" dirty="0"/>
-          </a:p>
-          <a:p>
-            <a:pPr algn="ctr"/>
-            <a:r>
-              <a:rPr lang="de-DE" sz="1400" b="1" dirty="0" err="1">
-                <a:solidFill>
-                  <a:srgbClr val="FF0000"/>
-                </a:solidFill>
-              </a:rPr>
-              <a:t>Kickout</a:t>
-            </a:r>
-            <a:r>
-              <a:rPr lang="de-DE" sz="1400" b="1" dirty="0">
-                <a:solidFill>
-                  <a:srgbClr val="FF0000"/>
-                </a:solidFill>
-              </a:rPr>
-              <a:t> (KO)</a:t>
-            </a:r>
-          </a:p>
-        </p:txBody>
-      </p:sp>
-      <p:sp>
-        <p:nvSpPr>
-          <p:cNvPr id="35" name="Textfeld 34">
-            <a:extLst>
-              <a:ext uri="{FF2B5EF4-FFF2-40B4-BE49-F238E27FC236}">
-                <a16:creationId xmlns:a16="http://schemas.microsoft.com/office/drawing/2014/main" id="{94888D6D-EBE0-A4CF-E266-6CF6B03693F4}"/>
-              </a:ext>
-            </a:extLst>
-          </p:cNvPr>
-          <p:cNvSpPr txBox="1"/>
-          <p:nvPr/>
-        </p:nvSpPr>
-        <p:spPr>
-          <a:xfrm>
-            <a:off x="526473" y="202680"/>
-            <a:ext cx="11096500" cy="584775"/>
-          </a:xfrm>
-          <a:prstGeom prst="rect">
-            <a:avLst/>
-          </a:prstGeom>
-          <a:noFill/>
-        </p:spPr>
-        <p:txBody>
-          <a:bodyPr wrap="square" rtlCol="0">
-            <a:spAutoFit/>
-          </a:bodyPr>
-          <a:lstStyle/>
-          <a:p>
-            <a:r>
-              <a:rPr lang="de-DE" sz="3200" dirty="0">
-                <a:solidFill>
-                  <a:schemeClr val="bg1"/>
-                </a:solidFill>
-                <a:highlight>
-                  <a:srgbClr val="008000"/>
-                </a:highlight>
-              </a:rPr>
-              <a:t>Projekt-Ziele</a:t>
-            </a:r>
-            <a:r>
-              <a:rPr lang="de-DE" sz="3200" dirty="0"/>
-              <a:t>  </a:t>
-            </a:r>
-            <a:r>
-              <a:rPr lang="de-DE" sz="2000" dirty="0"/>
-              <a:t>=  Kickoutprozess (</a:t>
-            </a:r>
-            <a:r>
-              <a:rPr lang="de-DE" sz="2000" b="1" u="sng" dirty="0"/>
-              <a:t>ML</a:t>
-            </a:r>
-            <a:r>
-              <a:rPr lang="de-DE" sz="2000" dirty="0"/>
-              <a:t>)   &amp;    Logdatenanalyse (</a:t>
-            </a:r>
-            <a:r>
-              <a:rPr lang="de-DE" sz="2000" b="1" u="sng" dirty="0"/>
-              <a:t>Dashboard</a:t>
-            </a:r>
-            <a:r>
-              <a:rPr lang="de-DE" sz="2000" dirty="0"/>
-              <a:t>)</a:t>
-            </a:r>
-          </a:p>
-        </p:txBody>
-      </p:sp>
-      <p:sp>
-        <p:nvSpPr>
-          <p:cNvPr id="3" name="Textfeld 2">
-            <a:extLst>
-              <a:ext uri="{FF2B5EF4-FFF2-40B4-BE49-F238E27FC236}">
-                <a16:creationId xmlns:a16="http://schemas.microsoft.com/office/drawing/2014/main" id="{C00DEFC9-CC83-3A00-0632-55559A6839A9}"/>
-              </a:ext>
-            </a:extLst>
-          </p:cNvPr>
-          <p:cNvSpPr txBox="1"/>
-          <p:nvPr/>
-        </p:nvSpPr>
-        <p:spPr>
-          <a:xfrm>
-            <a:off x="1160009" y="3289223"/>
-            <a:ext cx="2571653" cy="284693"/>
-          </a:xfrm>
-          <a:prstGeom prst="rect">
-            <a:avLst/>
-          </a:prstGeom>
-          <a:solidFill>
-            <a:srgbClr val="C00000"/>
-          </a:solidFill>
-        </p:spPr>
-        <p:txBody>
-          <a:bodyPr wrap="square">
-            <a:spAutoFit/>
-          </a:bodyPr>
-          <a:lstStyle/>
-          <a:p>
-            <a:pPr algn="ctr"/>
-            <a:r>
-              <a:rPr lang="de-DE" sz="1250" dirty="0">
+            <a:r>
+              <a:rPr lang="de-DE" dirty="0">
                 <a:solidFill>
                   <a:schemeClr val="bg1"/>
                 </a:solidFill>
               </a:rPr>
-              <a:t>möglicherweise Paketinhalt falsch</a:t>
-            </a:r>
-          </a:p>
-        </p:txBody>
-      </p:sp>
-      <p:cxnSp>
-        <p:nvCxnSpPr>
-          <p:cNvPr id="39" name="Gerader Verbinder 38">
-            <a:extLst>
-              <a:ext uri="{FF2B5EF4-FFF2-40B4-BE49-F238E27FC236}">
-                <a16:creationId xmlns:a16="http://schemas.microsoft.com/office/drawing/2014/main" id="{2B059B3F-98BA-70D7-2259-7E2915206A0C}"/>
-              </a:ext>
-            </a:extLst>
-          </p:cNvPr>
-          <p:cNvCxnSpPr>
-            <a:cxnSpLocks/>
-          </p:cNvCxnSpPr>
-          <p:nvPr/>
-        </p:nvCxnSpPr>
-        <p:spPr>
-          <a:xfrm>
-            <a:off x="8016607" y="3713735"/>
-            <a:ext cx="501997" cy="272045"/>
-          </a:xfrm>
-          <a:prstGeom prst="line">
-            <a:avLst/>
-          </a:prstGeom>
-          <a:ln w="31750">
-            <a:solidFill>
-              <a:srgbClr val="00FF00"/>
-            </a:solidFill>
-          </a:ln>
-        </p:spPr>
-        <p:style>
-          <a:lnRef idx="2">
-            <a:schemeClr val="accent1"/>
-          </a:lnRef>
-          <a:fillRef idx="0">
-            <a:schemeClr val="accent1"/>
-          </a:fillRef>
-          <a:effectRef idx="1">
-            <a:schemeClr val="accent1"/>
-          </a:effectRef>
-          <a:fontRef idx="minor">
-            <a:schemeClr val="tx1"/>
-          </a:fontRef>
-        </p:style>
-      </p:cxnSp>
-      <p:cxnSp>
-        <p:nvCxnSpPr>
-          <p:cNvPr id="41" name="Gerader Verbinder 40">
-            <a:extLst>
-              <a:ext uri="{FF2B5EF4-FFF2-40B4-BE49-F238E27FC236}">
-                <a16:creationId xmlns:a16="http://schemas.microsoft.com/office/drawing/2014/main" id="{68F36481-3C13-4E21-9997-71A655722C70}"/>
-              </a:ext>
-            </a:extLst>
-          </p:cNvPr>
-          <p:cNvCxnSpPr>
-            <a:cxnSpLocks/>
-          </p:cNvCxnSpPr>
-          <p:nvPr/>
-        </p:nvCxnSpPr>
-        <p:spPr>
-          <a:xfrm flipV="1">
-            <a:off x="8497395" y="3896070"/>
-            <a:ext cx="824709" cy="86535"/>
-          </a:xfrm>
-          <a:prstGeom prst="line">
-            <a:avLst/>
-          </a:prstGeom>
-          <a:ln w="31750">
-            <a:solidFill>
-              <a:srgbClr val="00FF00"/>
-            </a:solidFill>
-          </a:ln>
-        </p:spPr>
-        <p:style>
-          <a:lnRef idx="2">
-            <a:schemeClr val="accent1"/>
-          </a:lnRef>
-          <a:fillRef idx="0">
-            <a:schemeClr val="accent1"/>
-          </a:fillRef>
-          <a:effectRef idx="1">
-            <a:schemeClr val="accent1"/>
-          </a:effectRef>
-          <a:fontRef idx="minor">
-            <a:schemeClr val="tx1"/>
-          </a:fontRef>
-        </p:style>
-      </p:cxnSp>
-      <p:cxnSp>
-        <p:nvCxnSpPr>
-          <p:cNvPr id="43" name="Gerader Verbinder 42">
-            <a:extLst>
-              <a:ext uri="{FF2B5EF4-FFF2-40B4-BE49-F238E27FC236}">
-                <a16:creationId xmlns:a16="http://schemas.microsoft.com/office/drawing/2014/main" id="{FE678EC3-F136-4A6C-4B36-20F94608F791}"/>
-              </a:ext>
-            </a:extLst>
-          </p:cNvPr>
-          <p:cNvCxnSpPr>
-            <a:cxnSpLocks/>
-          </p:cNvCxnSpPr>
-          <p:nvPr/>
-        </p:nvCxnSpPr>
-        <p:spPr>
-          <a:xfrm>
-            <a:off x="8803794" y="3626255"/>
-            <a:ext cx="518310" cy="266640"/>
-          </a:xfrm>
-          <a:prstGeom prst="line">
-            <a:avLst/>
-          </a:prstGeom>
-          <a:ln w="31750">
-            <a:solidFill>
-              <a:srgbClr val="00FF00"/>
-            </a:solidFill>
-          </a:ln>
-        </p:spPr>
-        <p:style>
-          <a:lnRef idx="2">
-            <a:schemeClr val="accent1"/>
-          </a:lnRef>
-          <a:fillRef idx="0">
-            <a:schemeClr val="accent1"/>
-          </a:fillRef>
-          <a:effectRef idx="1">
-            <a:schemeClr val="accent1"/>
-          </a:effectRef>
-          <a:fontRef idx="minor">
-            <a:schemeClr val="tx1"/>
-          </a:fontRef>
-        </p:style>
-      </p:cxnSp>
-      <p:cxnSp>
-        <p:nvCxnSpPr>
-          <p:cNvPr id="44" name="Gerader Verbinder 43">
-            <a:extLst>
-              <a:ext uri="{FF2B5EF4-FFF2-40B4-BE49-F238E27FC236}">
-                <a16:creationId xmlns:a16="http://schemas.microsoft.com/office/drawing/2014/main" id="{F9262353-A53A-7AD7-B628-9FFF001B99C6}"/>
-              </a:ext>
-            </a:extLst>
-          </p:cNvPr>
-          <p:cNvCxnSpPr>
-            <a:cxnSpLocks/>
-          </p:cNvCxnSpPr>
-          <p:nvPr/>
-        </p:nvCxnSpPr>
-        <p:spPr>
-          <a:xfrm flipV="1">
-            <a:off x="8016607" y="3635268"/>
-            <a:ext cx="796423" cy="69454"/>
-          </a:xfrm>
-          <a:prstGeom prst="line">
-            <a:avLst/>
-          </a:prstGeom>
-          <a:ln w="31750">
-            <a:solidFill>
-              <a:srgbClr val="00FF00"/>
-            </a:solidFill>
-          </a:ln>
-        </p:spPr>
-        <p:style>
-          <a:lnRef idx="2">
-            <a:schemeClr val="accent1"/>
-          </a:lnRef>
-          <a:fillRef idx="0">
-            <a:schemeClr val="accent1"/>
-          </a:fillRef>
-          <a:effectRef idx="1">
-            <a:schemeClr val="accent1"/>
-          </a:effectRef>
-          <a:fontRef idx="minor">
-            <a:schemeClr val="tx1"/>
-          </a:fontRef>
-        </p:style>
-      </p:cxnSp>
-      <p:sp>
-        <p:nvSpPr>
-          <p:cNvPr id="46" name="Textfeld 45">
-            <a:extLst>
-              <a:ext uri="{FF2B5EF4-FFF2-40B4-BE49-F238E27FC236}">
-                <a16:creationId xmlns:a16="http://schemas.microsoft.com/office/drawing/2014/main" id="{9D3A7D31-872C-A00A-CF39-AC8B0432472C}"/>
-              </a:ext>
-            </a:extLst>
-          </p:cNvPr>
-          <p:cNvSpPr txBox="1"/>
-          <p:nvPr/>
-        </p:nvSpPr>
-        <p:spPr>
-          <a:xfrm rot="21093312">
-            <a:off x="8444558" y="3895962"/>
-            <a:ext cx="1117114" cy="369332"/>
-          </a:xfrm>
-          <a:prstGeom prst="rect">
-            <a:avLst/>
-          </a:prstGeom>
-          <a:noFill/>
-        </p:spPr>
-        <p:txBody>
-          <a:bodyPr wrap="square" rtlCol="0">
-            <a:spAutoFit/>
-          </a:bodyPr>
-          <a:lstStyle/>
-          <a:p>
-            <a:r>
-              <a:rPr lang="de-DE" b="1" dirty="0">
-                <a:solidFill>
-                  <a:srgbClr val="00FF00"/>
-                </a:solidFill>
-              </a:rPr>
-              <a:t>WAAGE</a:t>
-            </a:r>
-          </a:p>
-        </p:txBody>
-      </p:sp>
-      <p:sp>
-        <p:nvSpPr>
-          <p:cNvPr id="10" name="Pfeil: gestreift nach rechts 9">
-            <a:extLst>
-              <a:ext uri="{FF2B5EF4-FFF2-40B4-BE49-F238E27FC236}">
-                <a16:creationId xmlns:a16="http://schemas.microsoft.com/office/drawing/2014/main" id="{464474A5-66D7-9991-26A0-7987FB26CDB6}"/>
-              </a:ext>
-            </a:extLst>
-          </p:cNvPr>
-          <p:cNvSpPr/>
-          <p:nvPr/>
-        </p:nvSpPr>
-        <p:spPr>
-          <a:xfrm rot="21301293" flipH="1">
-            <a:off x="10708118" y="3408830"/>
-            <a:ext cx="1003849" cy="333439"/>
-          </a:xfrm>
-          <a:prstGeom prst="stripedRightArrow">
-            <a:avLst/>
-          </a:prstGeom>
-          <a:solidFill>
-            <a:srgbClr val="00FF00"/>
-          </a:solidFill>
-        </p:spPr>
-        <p:style>
-          <a:lnRef idx="2">
-            <a:schemeClr val="accent1">
-              <a:shade val="15000"/>
-            </a:schemeClr>
-          </a:lnRef>
-          <a:fillRef idx="1">
-            <a:schemeClr val="accent1"/>
-          </a:fillRef>
-          <a:effectRef idx="0">
-            <a:schemeClr val="accent1"/>
-          </a:effectRef>
-          <a:fontRef idx="minor">
-            <a:schemeClr val="lt1"/>
-          </a:fontRef>
-        </p:style>
-        <p:txBody>
-          <a:bodyPr rtlCol="0" anchor="ctr"/>
-          <a:lstStyle/>
-          <a:p>
-            <a:pPr algn="ctr"/>
-            <a:r>
-              <a:rPr lang="de-DE" sz="1000" dirty="0">
-                <a:solidFill>
-                  <a:schemeClr val="bg1">
-                    <a:lumMod val="65000"/>
-                  </a:schemeClr>
-                </a:solidFill>
-              </a:rPr>
-              <a:t>Förderband</a:t>
-            </a:r>
-          </a:p>
-        </p:txBody>
-      </p:sp>
-      <p:sp>
-        <p:nvSpPr>
-          <p:cNvPr id="32" name="Textfeld 31">
-            <a:extLst>
-              <a:ext uri="{FF2B5EF4-FFF2-40B4-BE49-F238E27FC236}">
-                <a16:creationId xmlns:a16="http://schemas.microsoft.com/office/drawing/2014/main" id="{5849860B-1EA1-FFDD-12BA-2F9C4E1BDB08}"/>
-              </a:ext>
-            </a:extLst>
-          </p:cNvPr>
-          <p:cNvSpPr txBox="1"/>
-          <p:nvPr/>
-        </p:nvSpPr>
-        <p:spPr>
-          <a:xfrm>
-            <a:off x="299703" y="2380067"/>
-            <a:ext cx="2461960" cy="261610"/>
-          </a:xfrm>
-          <a:prstGeom prst="rect">
-            <a:avLst/>
-          </a:prstGeom>
-          <a:noFill/>
-        </p:spPr>
-        <p:txBody>
-          <a:bodyPr wrap="square" rtlCol="0">
-            <a:spAutoFit/>
-          </a:bodyPr>
-          <a:lstStyle/>
-          <a:p>
-            <a:pPr algn="ctr"/>
-            <a:r>
-              <a:rPr lang="de-DE" sz="1100" dirty="0">
-                <a:solidFill>
-                  <a:srgbClr val="00B050"/>
-                </a:solidFill>
-              </a:rPr>
-              <a:t>Gewichtsdifferenz passt</a:t>
-            </a:r>
-          </a:p>
-        </p:txBody>
-      </p:sp>
-      <p:sp>
-        <p:nvSpPr>
-          <p:cNvPr id="42" name="Rechteck 41">
-            <a:extLst>
-              <a:ext uri="{FF2B5EF4-FFF2-40B4-BE49-F238E27FC236}">
-                <a16:creationId xmlns:a16="http://schemas.microsoft.com/office/drawing/2014/main" id="{50534AD5-CB3C-4F27-C10A-94563C33117A}"/>
-              </a:ext>
-            </a:extLst>
-          </p:cNvPr>
-          <p:cNvSpPr/>
-          <p:nvPr/>
-        </p:nvSpPr>
-        <p:spPr>
-          <a:xfrm>
-            <a:off x="4486427" y="1310809"/>
-            <a:ext cx="4956249" cy="3131636"/>
-          </a:xfrm>
-          <a:prstGeom prst="rect">
-            <a:avLst/>
-          </a:prstGeom>
-          <a:noFill/>
-          <a:ln w="38100">
-            <a:solidFill>
-              <a:srgbClr val="FFC000"/>
-            </a:solidFill>
-          </a:ln>
-        </p:spPr>
-        <p:style>
-          <a:lnRef idx="2">
-            <a:schemeClr val="accent1">
-              <a:shade val="15000"/>
-            </a:schemeClr>
-          </a:lnRef>
-          <a:fillRef idx="1">
-            <a:schemeClr val="accent1"/>
-          </a:fillRef>
-          <a:effectRef idx="0">
-            <a:schemeClr val="accent1"/>
-          </a:effectRef>
-          <a:fontRef idx="minor">
-            <a:schemeClr val="lt1"/>
-          </a:fontRef>
-        </p:style>
-        <p:txBody>
-          <a:bodyPr rtlCol="0" anchor="ctr"/>
-          <a:lstStyle/>
-          <a:p>
-            <a:pPr algn="ctr"/>
-            <a:endParaRPr lang="de-DE"/>
-          </a:p>
-        </p:txBody>
-      </p:sp>
-      <p:sp>
-        <p:nvSpPr>
-          <p:cNvPr id="51" name="Ellipse 50">
-            <a:extLst>
-              <a:ext uri="{FF2B5EF4-FFF2-40B4-BE49-F238E27FC236}">
-                <a16:creationId xmlns:a16="http://schemas.microsoft.com/office/drawing/2014/main" id="{12539889-9601-562C-8507-A9205A161A19}"/>
-              </a:ext>
-            </a:extLst>
-          </p:cNvPr>
-          <p:cNvSpPr/>
-          <p:nvPr/>
-        </p:nvSpPr>
-        <p:spPr>
-          <a:xfrm>
-            <a:off x="5730839" y="1901786"/>
-            <a:ext cx="676351" cy="664624"/>
-          </a:xfrm>
-          <a:prstGeom prst="ellipse">
-            <a:avLst/>
-          </a:prstGeom>
-          <a:noFill/>
-        </p:spPr>
-        <p:style>
-          <a:lnRef idx="2">
-            <a:schemeClr val="accent1">
-              <a:shade val="15000"/>
-            </a:schemeClr>
-          </a:lnRef>
-          <a:fillRef idx="1">
-            <a:schemeClr val="accent1"/>
-          </a:fillRef>
-          <a:effectRef idx="0">
-            <a:schemeClr val="accent1"/>
-          </a:effectRef>
-          <a:fontRef idx="minor">
-            <a:schemeClr val="lt1"/>
-          </a:fontRef>
-        </p:style>
-        <p:txBody>
-          <a:bodyPr rtlCol="0" anchor="ctr"/>
-          <a:lstStyle/>
-          <a:p>
-            <a:pPr algn="ctr"/>
-            <a:endParaRPr lang="de-DE"/>
-          </a:p>
-        </p:txBody>
-      </p:sp>
-      <p:sp>
-        <p:nvSpPr>
-          <p:cNvPr id="54" name="Textfeld 53">
-            <a:extLst>
-              <a:ext uri="{FF2B5EF4-FFF2-40B4-BE49-F238E27FC236}">
-                <a16:creationId xmlns:a16="http://schemas.microsoft.com/office/drawing/2014/main" id="{2647B621-73A9-8899-D985-08BB4AF34B4D}"/>
-              </a:ext>
-            </a:extLst>
-          </p:cNvPr>
-          <p:cNvSpPr txBox="1"/>
-          <p:nvPr/>
-        </p:nvSpPr>
-        <p:spPr>
-          <a:xfrm>
-            <a:off x="4403623" y="1292905"/>
-            <a:ext cx="1815797" cy="307777"/>
-          </a:xfrm>
-          <a:prstGeom prst="rect">
-            <a:avLst/>
-          </a:prstGeom>
-          <a:noFill/>
-        </p:spPr>
-        <p:txBody>
-          <a:bodyPr wrap="square" rtlCol="0">
-            <a:spAutoFit/>
-          </a:bodyPr>
-          <a:lstStyle/>
-          <a:p>
-            <a:r>
-              <a:rPr lang="de-DE" sz="1400" b="1" dirty="0">
-                <a:highlight>
-                  <a:srgbClr val="00FF00"/>
-                </a:highlight>
-              </a:rPr>
-              <a:t>Logfile-Erzeugung</a:t>
-            </a:r>
-            <a:endParaRPr lang="de-DE" sz="1400" dirty="0">
-              <a:highlight>
-                <a:srgbClr val="00FF00"/>
-              </a:highlight>
+              <a:t>Insight Log-Data</a:t>
+            </a:r>
+            <a:endParaRPr lang="de-DE" sz="1100" dirty="0">
+              <a:solidFill>
+                <a:schemeClr val="bg1"/>
+              </a:solidFill>
             </a:endParaRPr>
           </a:p>
         </p:txBody>
       </p:sp>
       <p:pic>
         <p:nvPicPr>
-          <p:cNvPr id="57" name="Grafik 56">
-            <a:extLst>
-              <a:ext uri="{FF2B5EF4-FFF2-40B4-BE49-F238E27FC236}">
-                <a16:creationId xmlns:a16="http://schemas.microsoft.com/office/drawing/2014/main" id="{3E336A0C-F2F5-493E-3920-917FA13125E4}"/>
+          <p:cNvPr id="4" name="Grafik 3">
+            <a:extLst>
+              <a:ext uri="{FF2B5EF4-FFF2-40B4-BE49-F238E27FC236}">
+                <a16:creationId xmlns:a16="http://schemas.microsoft.com/office/drawing/2014/main" id="{DB5B1C7A-542E-D029-CEB3-F2F7C8509450}"/>
               </a:ext>
             </a:extLst>
           </p:cNvPr>
@@ -4868,1401 +3993,8 @@
         </p:blipFill>
         <p:spPr>
           <a:xfrm>
-            <a:off x="4914999" y="3812973"/>
-            <a:ext cx="701555" cy="495215"/>
-          </a:xfrm>
-          <a:prstGeom prst="rect">
-            <a:avLst/>
-          </a:prstGeom>
-        </p:spPr>
-      </p:pic>
-      <p:pic>
-        <p:nvPicPr>
-          <p:cNvPr id="58" name="Grafik 57">
-            <a:extLst>
-              <a:ext uri="{FF2B5EF4-FFF2-40B4-BE49-F238E27FC236}">
-                <a16:creationId xmlns:a16="http://schemas.microsoft.com/office/drawing/2014/main" id="{CED546AA-F452-D879-AB61-C8DCFBE41741}"/>
-              </a:ext>
-            </a:extLst>
-          </p:cNvPr>
-          <p:cNvPicPr>
-            <a:picLocks noChangeAspect="1"/>
-          </p:cNvPicPr>
-          <p:nvPr/>
-        </p:nvPicPr>
-        <p:blipFill>
-          <a:blip r:embed="rId2"/>
-          <a:stretch>
-            <a:fillRect/>
-          </a:stretch>
-        </p:blipFill>
-        <p:spPr>
-          <a:xfrm>
-            <a:off x="8394745" y="3531351"/>
-            <a:ext cx="678674" cy="479064"/>
-          </a:xfrm>
-          <a:prstGeom prst="rect">
-            <a:avLst/>
-          </a:prstGeom>
-        </p:spPr>
-      </p:pic>
-      <p:sp>
-        <p:nvSpPr>
-          <p:cNvPr id="61" name="Rechteck 60">
-            <a:extLst>
-              <a:ext uri="{FF2B5EF4-FFF2-40B4-BE49-F238E27FC236}">
-                <a16:creationId xmlns:a16="http://schemas.microsoft.com/office/drawing/2014/main" id="{8529B105-C789-DB9C-1886-7056313EC534}"/>
-              </a:ext>
-            </a:extLst>
-          </p:cNvPr>
-          <p:cNvSpPr/>
-          <p:nvPr/>
-        </p:nvSpPr>
-        <p:spPr>
-          <a:xfrm>
-            <a:off x="5196920" y="3468915"/>
-            <a:ext cx="45719" cy="330352"/>
-          </a:xfrm>
-          <a:prstGeom prst="rect">
-            <a:avLst/>
-          </a:prstGeom>
-          <a:solidFill>
-            <a:schemeClr val="tx1"/>
-          </a:solidFill>
-        </p:spPr>
-        <p:style>
-          <a:lnRef idx="2">
-            <a:schemeClr val="accent1">
-              <a:shade val="15000"/>
-            </a:schemeClr>
-          </a:lnRef>
-          <a:fillRef idx="1">
-            <a:schemeClr val="accent1"/>
-          </a:fillRef>
-          <a:effectRef idx="0">
-            <a:schemeClr val="accent1"/>
-          </a:effectRef>
-          <a:fontRef idx="minor">
-            <a:schemeClr val="lt1"/>
-          </a:fontRef>
-        </p:style>
-        <p:txBody>
-          <a:bodyPr rtlCol="0" anchor="ctr"/>
-          <a:lstStyle/>
-          <a:p>
-            <a:pPr algn="ctr"/>
-            <a:endParaRPr lang="de-DE"/>
-          </a:p>
-        </p:txBody>
-      </p:sp>
-      <p:sp>
-        <p:nvSpPr>
-          <p:cNvPr id="62" name="Rechteck 61">
-            <a:extLst>
-              <a:ext uri="{FF2B5EF4-FFF2-40B4-BE49-F238E27FC236}">
-                <a16:creationId xmlns:a16="http://schemas.microsoft.com/office/drawing/2014/main" id="{F8F4C57A-7404-CEF7-7E1E-6A669C683A64}"/>
-              </a:ext>
-            </a:extLst>
-          </p:cNvPr>
-          <p:cNvSpPr/>
-          <p:nvPr/>
-        </p:nvSpPr>
-        <p:spPr>
-          <a:xfrm rot="5400000">
-            <a:off x="5190163" y="3680075"/>
-            <a:ext cx="61750" cy="265797"/>
-          </a:xfrm>
-          <a:prstGeom prst="rect">
-            <a:avLst/>
-          </a:prstGeom>
-          <a:solidFill>
-            <a:schemeClr val="tx1"/>
-          </a:solidFill>
-        </p:spPr>
-        <p:style>
-          <a:lnRef idx="2">
-            <a:schemeClr val="accent1">
-              <a:shade val="15000"/>
-            </a:schemeClr>
-          </a:lnRef>
-          <a:fillRef idx="1">
-            <a:schemeClr val="accent1"/>
-          </a:fillRef>
-          <a:effectRef idx="0">
-            <a:schemeClr val="accent1"/>
-          </a:effectRef>
-          <a:fontRef idx="minor">
-            <a:schemeClr val="lt1"/>
-          </a:fontRef>
-        </p:style>
-        <p:txBody>
-          <a:bodyPr rtlCol="0" anchor="ctr"/>
-          <a:lstStyle/>
-          <a:p>
-            <a:pPr algn="ctr"/>
-            <a:endParaRPr lang="de-DE"/>
-          </a:p>
-        </p:txBody>
-      </p:sp>
-      <p:pic>
-        <p:nvPicPr>
-          <p:cNvPr id="63" name="Grafik 62">
-            <a:extLst>
-              <a:ext uri="{FF2B5EF4-FFF2-40B4-BE49-F238E27FC236}">
-                <a16:creationId xmlns:a16="http://schemas.microsoft.com/office/drawing/2014/main" id="{F0F38478-C862-5637-03F8-BD6690A806A5}"/>
-              </a:ext>
-            </a:extLst>
-          </p:cNvPr>
-          <p:cNvPicPr>
-            <a:picLocks noChangeAspect="1"/>
-          </p:cNvPicPr>
-          <p:nvPr/>
-        </p:nvPicPr>
-        <p:blipFill>
-          <a:blip r:embed="rId2"/>
-          <a:stretch>
-            <a:fillRect/>
-          </a:stretch>
-        </p:blipFill>
-        <p:spPr>
-          <a:xfrm>
-            <a:off x="6568160" y="3704722"/>
-            <a:ext cx="678674" cy="479064"/>
-          </a:xfrm>
-          <a:prstGeom prst="rect">
-            <a:avLst/>
-          </a:prstGeom>
-        </p:spPr>
-      </p:pic>
-      <p:sp>
-        <p:nvSpPr>
-          <p:cNvPr id="64" name="Textfeld 63">
-            <a:extLst>
-              <a:ext uri="{FF2B5EF4-FFF2-40B4-BE49-F238E27FC236}">
-                <a16:creationId xmlns:a16="http://schemas.microsoft.com/office/drawing/2014/main" id="{42301193-ED65-8936-0906-8E5F9CE03867}"/>
-              </a:ext>
-            </a:extLst>
-          </p:cNvPr>
-          <p:cNvSpPr txBox="1"/>
-          <p:nvPr/>
-        </p:nvSpPr>
-        <p:spPr>
-          <a:xfrm>
-            <a:off x="4670435" y="3280589"/>
-            <a:ext cx="1141425" cy="246221"/>
-          </a:xfrm>
-          <a:prstGeom prst="rect">
-            <a:avLst/>
-          </a:prstGeom>
-          <a:noFill/>
-        </p:spPr>
-        <p:txBody>
-          <a:bodyPr wrap="square" rtlCol="0">
-            <a:spAutoFit/>
-          </a:bodyPr>
-          <a:lstStyle/>
-          <a:p>
-            <a:r>
-              <a:rPr lang="de-DE" sz="1000" i="1" dirty="0"/>
-              <a:t>Adressaufkleber</a:t>
-            </a:r>
-          </a:p>
-        </p:txBody>
-      </p:sp>
-      <p:sp>
-        <p:nvSpPr>
-          <p:cNvPr id="65" name="Textfeld 64">
-            <a:extLst>
-              <a:ext uri="{FF2B5EF4-FFF2-40B4-BE49-F238E27FC236}">
-                <a16:creationId xmlns:a16="http://schemas.microsoft.com/office/drawing/2014/main" id="{202AD7BE-CB82-D89C-A647-526B9B1B3C23}"/>
-              </a:ext>
-            </a:extLst>
-          </p:cNvPr>
-          <p:cNvSpPr txBox="1"/>
-          <p:nvPr/>
-        </p:nvSpPr>
-        <p:spPr>
-          <a:xfrm>
-            <a:off x="6349597" y="2121213"/>
-            <a:ext cx="1342223" cy="246221"/>
-          </a:xfrm>
-          <a:prstGeom prst="rect">
-            <a:avLst/>
-          </a:prstGeom>
-          <a:noFill/>
-        </p:spPr>
-        <p:txBody>
-          <a:bodyPr wrap="square" rtlCol="0">
-            <a:spAutoFit/>
-          </a:bodyPr>
-          <a:lstStyle/>
-          <a:p>
-            <a:r>
-              <a:rPr lang="de-DE" sz="1000" i="1" dirty="0"/>
-              <a:t>← Sticker-Rollen →</a:t>
-            </a:r>
-          </a:p>
-        </p:txBody>
-      </p:sp>
-      <p:pic>
-        <p:nvPicPr>
-          <p:cNvPr id="66" name="Grafik 65">
-            <a:extLst>
-              <a:ext uri="{FF2B5EF4-FFF2-40B4-BE49-F238E27FC236}">
-                <a16:creationId xmlns:a16="http://schemas.microsoft.com/office/drawing/2014/main" id="{A91B2873-38C5-1E20-56A2-09B28364B1C0}"/>
-              </a:ext>
-            </a:extLst>
-          </p:cNvPr>
-          <p:cNvPicPr>
-            <a:picLocks noChangeAspect="1"/>
-          </p:cNvPicPr>
-          <p:nvPr/>
-        </p:nvPicPr>
-        <p:blipFill>
-          <a:blip r:embed="rId2"/>
-          <a:stretch>
-            <a:fillRect/>
-          </a:stretch>
-        </p:blipFill>
-        <p:spPr>
-          <a:xfrm>
-            <a:off x="681699" y="4254223"/>
-            <a:ext cx="701555" cy="495215"/>
-          </a:xfrm>
-          <a:prstGeom prst="rect">
-            <a:avLst/>
-          </a:prstGeom>
-        </p:spPr>
-      </p:pic>
-      <p:pic>
-        <p:nvPicPr>
-          <p:cNvPr id="69" name="Grafik 68">
-            <a:extLst>
-              <a:ext uri="{FF2B5EF4-FFF2-40B4-BE49-F238E27FC236}">
-                <a16:creationId xmlns:a16="http://schemas.microsoft.com/office/drawing/2014/main" id="{79C8812A-D0BF-8FAC-13A3-3774DB0DBD3D}"/>
-              </a:ext>
-            </a:extLst>
-          </p:cNvPr>
-          <p:cNvPicPr>
-            <a:picLocks noChangeAspect="1"/>
-          </p:cNvPicPr>
-          <p:nvPr/>
-        </p:nvPicPr>
-        <p:blipFill>
-          <a:blip r:embed="rId2"/>
-          <a:stretch>
-            <a:fillRect/>
-          </a:stretch>
-        </p:blipFill>
-        <p:spPr>
-          <a:xfrm>
-            <a:off x="9922989" y="3398923"/>
-            <a:ext cx="678674" cy="479064"/>
-          </a:xfrm>
-          <a:prstGeom prst="rect">
-            <a:avLst/>
-          </a:prstGeom>
-        </p:spPr>
-      </p:pic>
-      <p:sp>
-        <p:nvSpPr>
-          <p:cNvPr id="70" name="Rechteck 69">
-            <a:extLst>
-              <a:ext uri="{FF2B5EF4-FFF2-40B4-BE49-F238E27FC236}">
-                <a16:creationId xmlns:a16="http://schemas.microsoft.com/office/drawing/2014/main" id="{8DE02FD1-19AD-2EA8-6777-69A1AC764F7F}"/>
-              </a:ext>
-            </a:extLst>
-          </p:cNvPr>
-          <p:cNvSpPr/>
-          <p:nvPr/>
-        </p:nvSpPr>
-        <p:spPr>
-          <a:xfrm>
-            <a:off x="9999499" y="1931885"/>
-            <a:ext cx="433217" cy="163950"/>
-          </a:xfrm>
-          <a:prstGeom prst="rect">
-            <a:avLst/>
-          </a:prstGeom>
-          <a:noFill/>
-          <a:ln>
-            <a:solidFill>
-              <a:schemeClr val="tx1"/>
-            </a:solidFill>
-          </a:ln>
-        </p:spPr>
-        <p:style>
-          <a:lnRef idx="2">
-            <a:schemeClr val="accent1">
-              <a:shade val="15000"/>
-            </a:schemeClr>
-          </a:lnRef>
-          <a:fillRef idx="1">
-            <a:schemeClr val="accent1"/>
-          </a:fillRef>
-          <a:effectRef idx="0">
-            <a:schemeClr val="accent1"/>
-          </a:effectRef>
-          <a:fontRef idx="minor">
-            <a:schemeClr val="lt1"/>
-          </a:fontRef>
-        </p:style>
-        <p:txBody>
-          <a:bodyPr rtlCol="0" anchor="ctr"/>
-          <a:lstStyle/>
-          <a:p>
-            <a:pPr algn="ctr"/>
-            <a:endParaRPr lang="de-DE"/>
-          </a:p>
-        </p:txBody>
-      </p:sp>
-      <p:cxnSp>
-        <p:nvCxnSpPr>
-          <p:cNvPr id="72" name="Gerader Verbinder 71">
-            <a:extLst>
-              <a:ext uri="{FF2B5EF4-FFF2-40B4-BE49-F238E27FC236}">
-                <a16:creationId xmlns:a16="http://schemas.microsoft.com/office/drawing/2014/main" id="{74500EF2-AC51-CCFB-78BF-951BF4842FD9}"/>
-              </a:ext>
-            </a:extLst>
-          </p:cNvPr>
-          <p:cNvCxnSpPr>
-            <a:cxnSpLocks/>
-            <a:stCxn id="70" idx="2"/>
-          </p:cNvCxnSpPr>
-          <p:nvPr/>
-        </p:nvCxnSpPr>
-        <p:spPr>
-          <a:xfrm flipH="1">
-            <a:off x="10143095" y="2095835"/>
-            <a:ext cx="73013" cy="1270066"/>
-          </a:xfrm>
-          <a:prstGeom prst="line">
-            <a:avLst/>
-          </a:prstGeom>
-          <a:ln>
-            <a:solidFill>
-              <a:schemeClr val="accent2"/>
-            </a:solidFill>
-            <a:prstDash val="sysDot"/>
-          </a:ln>
-        </p:spPr>
-        <p:style>
-          <a:lnRef idx="2">
-            <a:schemeClr val="accent1"/>
-          </a:lnRef>
-          <a:fillRef idx="0">
-            <a:schemeClr val="accent1"/>
-          </a:fillRef>
-          <a:effectRef idx="1">
-            <a:schemeClr val="accent1"/>
-          </a:effectRef>
-          <a:fontRef idx="minor">
-            <a:schemeClr val="tx1"/>
-          </a:fontRef>
-        </p:style>
-      </p:cxnSp>
-      <p:cxnSp>
-        <p:nvCxnSpPr>
-          <p:cNvPr id="74" name="Gerader Verbinder 73">
-            <a:extLst>
-              <a:ext uri="{FF2B5EF4-FFF2-40B4-BE49-F238E27FC236}">
-                <a16:creationId xmlns:a16="http://schemas.microsoft.com/office/drawing/2014/main" id="{FF9AC8C1-1151-13AF-7083-5C7A7ECDDCB0}"/>
-              </a:ext>
-            </a:extLst>
-          </p:cNvPr>
-          <p:cNvCxnSpPr>
-            <a:cxnSpLocks/>
-            <a:stCxn id="70" idx="2"/>
-            <a:endCxn id="69" idx="0"/>
-          </p:cNvCxnSpPr>
-          <p:nvPr/>
-        </p:nvCxnSpPr>
-        <p:spPr>
-          <a:xfrm>
-            <a:off x="10216108" y="2095835"/>
-            <a:ext cx="46218" cy="1303088"/>
-          </a:xfrm>
-          <a:prstGeom prst="line">
-            <a:avLst/>
-          </a:prstGeom>
-          <a:ln>
-            <a:solidFill>
-              <a:schemeClr val="accent2"/>
-            </a:solidFill>
-            <a:prstDash val="sysDot"/>
-          </a:ln>
-        </p:spPr>
-        <p:style>
-          <a:lnRef idx="2">
-            <a:schemeClr val="accent1"/>
-          </a:lnRef>
-          <a:fillRef idx="0">
-            <a:schemeClr val="accent1"/>
-          </a:fillRef>
-          <a:effectRef idx="1">
-            <a:schemeClr val="accent1"/>
-          </a:effectRef>
-          <a:fontRef idx="minor">
-            <a:schemeClr val="tx1"/>
-          </a:fontRef>
-        </p:style>
-      </p:cxnSp>
-      <p:cxnSp>
-        <p:nvCxnSpPr>
-          <p:cNvPr id="77" name="Gerader Verbinder 76">
-            <a:extLst>
-              <a:ext uri="{FF2B5EF4-FFF2-40B4-BE49-F238E27FC236}">
-                <a16:creationId xmlns:a16="http://schemas.microsoft.com/office/drawing/2014/main" id="{8F5B753F-3EE0-EC65-9B5D-5FB80ABA0D26}"/>
-              </a:ext>
-            </a:extLst>
-          </p:cNvPr>
-          <p:cNvCxnSpPr>
-            <a:cxnSpLocks/>
-            <a:stCxn id="70" idx="2"/>
-          </p:cNvCxnSpPr>
-          <p:nvPr/>
-        </p:nvCxnSpPr>
-        <p:spPr>
-          <a:xfrm>
-            <a:off x="10216108" y="2095835"/>
-            <a:ext cx="128843" cy="1254237"/>
-          </a:xfrm>
-          <a:prstGeom prst="line">
-            <a:avLst/>
-          </a:prstGeom>
-          <a:ln>
-            <a:solidFill>
-              <a:schemeClr val="accent2"/>
-            </a:solidFill>
-            <a:prstDash val="sysDot"/>
-          </a:ln>
-        </p:spPr>
-        <p:style>
-          <a:lnRef idx="2">
-            <a:schemeClr val="accent1"/>
-          </a:lnRef>
-          <a:fillRef idx="0">
-            <a:schemeClr val="accent1"/>
-          </a:fillRef>
-          <a:effectRef idx="1">
-            <a:schemeClr val="accent1"/>
-          </a:effectRef>
-          <a:fontRef idx="minor">
-            <a:schemeClr val="tx1"/>
-          </a:fontRef>
-        </p:style>
-      </p:cxnSp>
-      <p:cxnSp>
-        <p:nvCxnSpPr>
-          <p:cNvPr id="97" name="Gerade Verbindung mit Pfeil 96">
-            <a:extLst>
-              <a:ext uri="{FF2B5EF4-FFF2-40B4-BE49-F238E27FC236}">
-                <a16:creationId xmlns:a16="http://schemas.microsoft.com/office/drawing/2014/main" id="{E38919BF-411D-1B3A-6DC5-32542550B182}"/>
-              </a:ext>
-            </a:extLst>
-          </p:cNvPr>
-          <p:cNvCxnSpPr>
-            <a:cxnSpLocks/>
-          </p:cNvCxnSpPr>
-          <p:nvPr/>
-        </p:nvCxnSpPr>
-        <p:spPr>
-          <a:xfrm>
-            <a:off x="7380715" y="692543"/>
-            <a:ext cx="0" cy="569415"/>
-          </a:xfrm>
-          <a:prstGeom prst="straightConnector1">
-            <a:avLst/>
-          </a:prstGeom>
-          <a:ln w="28575">
-            <a:solidFill>
-              <a:srgbClr val="FFC000"/>
-            </a:solidFill>
-            <a:tailEnd type="triangle"/>
-          </a:ln>
-        </p:spPr>
-        <p:style>
-          <a:lnRef idx="2">
-            <a:schemeClr val="accent1"/>
-          </a:lnRef>
-          <a:fillRef idx="0">
-            <a:schemeClr val="accent1"/>
-          </a:fillRef>
-          <a:effectRef idx="1">
-            <a:schemeClr val="accent1"/>
-          </a:effectRef>
-          <a:fontRef idx="minor">
-            <a:schemeClr val="tx1"/>
-          </a:fontRef>
-        </p:style>
-      </p:cxnSp>
-      <p:cxnSp>
-        <p:nvCxnSpPr>
-          <p:cNvPr id="100" name="Gerade Verbindung mit Pfeil 99">
-            <a:extLst>
-              <a:ext uri="{FF2B5EF4-FFF2-40B4-BE49-F238E27FC236}">
-                <a16:creationId xmlns:a16="http://schemas.microsoft.com/office/drawing/2014/main" id="{FE6820BF-A028-D55B-DD88-659734136C2A}"/>
-              </a:ext>
-            </a:extLst>
-          </p:cNvPr>
-          <p:cNvCxnSpPr>
-            <a:cxnSpLocks/>
-          </p:cNvCxnSpPr>
-          <p:nvPr/>
-        </p:nvCxnSpPr>
-        <p:spPr>
-          <a:xfrm flipH="1">
-            <a:off x="3482455" y="749869"/>
-            <a:ext cx="12666" cy="2083784"/>
-          </a:xfrm>
-          <a:prstGeom prst="straightConnector1">
-            <a:avLst/>
-          </a:prstGeom>
-          <a:ln w="28575">
-            <a:solidFill>
-              <a:srgbClr val="FFC000"/>
-            </a:solidFill>
-            <a:tailEnd type="triangle"/>
-          </a:ln>
-        </p:spPr>
-        <p:style>
-          <a:lnRef idx="2">
-            <a:schemeClr val="accent1"/>
-          </a:lnRef>
-          <a:fillRef idx="0">
-            <a:schemeClr val="accent1"/>
-          </a:fillRef>
-          <a:effectRef idx="1">
-            <a:schemeClr val="accent1"/>
-          </a:effectRef>
-          <a:fontRef idx="minor">
-            <a:schemeClr val="tx1"/>
-          </a:fontRef>
-        </p:style>
-      </p:cxnSp>
-      <p:sp>
-        <p:nvSpPr>
-          <p:cNvPr id="104" name="Textfeld 103">
-            <a:extLst>
-              <a:ext uri="{FF2B5EF4-FFF2-40B4-BE49-F238E27FC236}">
-                <a16:creationId xmlns:a16="http://schemas.microsoft.com/office/drawing/2014/main" id="{E2B6967C-F9F2-C624-A86A-8B152EA2E826}"/>
-              </a:ext>
-            </a:extLst>
-          </p:cNvPr>
-          <p:cNvSpPr txBox="1"/>
-          <p:nvPr/>
-        </p:nvSpPr>
-        <p:spPr>
-          <a:xfrm rot="16200000">
-            <a:off x="10596299" y="3100674"/>
-            <a:ext cx="2542959" cy="369332"/>
-          </a:xfrm>
-          <a:prstGeom prst="rect">
-            <a:avLst/>
-          </a:prstGeom>
-          <a:noFill/>
-        </p:spPr>
-        <p:txBody>
-          <a:bodyPr wrap="square" rtlCol="0">
-            <a:spAutoFit/>
-          </a:bodyPr>
-          <a:lstStyle/>
-          <a:p>
-            <a:r>
-              <a:rPr lang="de-DE" dirty="0">
-                <a:solidFill>
-                  <a:schemeClr val="bg1">
-                    <a:lumMod val="65000"/>
-                  </a:schemeClr>
-                </a:solidFill>
-              </a:rPr>
-              <a:t>Pack-Arbeitsstationen</a:t>
-            </a:r>
-          </a:p>
-        </p:txBody>
-      </p:sp>
-      <p:sp>
-        <p:nvSpPr>
-          <p:cNvPr id="109" name="Textfeld 108">
-            <a:extLst>
-              <a:ext uri="{FF2B5EF4-FFF2-40B4-BE49-F238E27FC236}">
-                <a16:creationId xmlns:a16="http://schemas.microsoft.com/office/drawing/2014/main" id="{1AA1E61A-2934-1F91-4EEE-E75B2D144B5C}"/>
-              </a:ext>
-            </a:extLst>
-          </p:cNvPr>
-          <p:cNvSpPr txBox="1"/>
-          <p:nvPr/>
-        </p:nvSpPr>
-        <p:spPr>
-          <a:xfrm rot="16200000">
-            <a:off x="-936780" y="3260068"/>
-            <a:ext cx="2542959" cy="369332"/>
-          </a:xfrm>
-          <a:prstGeom prst="rect">
-            <a:avLst/>
-          </a:prstGeom>
-          <a:noFill/>
-        </p:spPr>
-        <p:txBody>
-          <a:bodyPr wrap="square" rtlCol="0">
-            <a:spAutoFit/>
-          </a:bodyPr>
-          <a:lstStyle/>
-          <a:p>
-            <a:pPr algn="ctr"/>
-            <a:r>
-              <a:rPr lang="de-DE" dirty="0">
-                <a:solidFill>
-                  <a:schemeClr val="bg1">
-                    <a:lumMod val="65000"/>
-                  </a:schemeClr>
-                </a:solidFill>
-              </a:rPr>
-              <a:t>LKW - Verladung</a:t>
-            </a:r>
-          </a:p>
-        </p:txBody>
-      </p:sp>
-      <p:cxnSp>
-        <p:nvCxnSpPr>
-          <p:cNvPr id="110" name="Gerade Verbindung mit Pfeil 109">
-            <a:extLst>
-              <a:ext uri="{FF2B5EF4-FFF2-40B4-BE49-F238E27FC236}">
-                <a16:creationId xmlns:a16="http://schemas.microsoft.com/office/drawing/2014/main" id="{86989C99-8040-57AA-8994-203FD2982CC6}"/>
-              </a:ext>
-            </a:extLst>
-          </p:cNvPr>
-          <p:cNvCxnSpPr>
-            <a:cxnSpLocks/>
-          </p:cNvCxnSpPr>
-          <p:nvPr/>
-        </p:nvCxnSpPr>
-        <p:spPr>
-          <a:xfrm flipH="1">
-            <a:off x="2349805" y="2616654"/>
-            <a:ext cx="3266749" cy="0"/>
-          </a:xfrm>
-          <a:prstGeom prst="straightConnector1">
-            <a:avLst/>
-          </a:prstGeom>
-          <a:ln w="22225">
-            <a:solidFill>
-              <a:schemeClr val="tx1"/>
-            </a:solidFill>
-            <a:prstDash val="dash"/>
-            <a:tailEnd type="none"/>
-          </a:ln>
-        </p:spPr>
-        <p:style>
-          <a:lnRef idx="2">
-            <a:schemeClr val="accent1"/>
-          </a:lnRef>
-          <a:fillRef idx="0">
-            <a:schemeClr val="accent1"/>
-          </a:fillRef>
-          <a:effectRef idx="1">
-            <a:schemeClr val="accent1"/>
-          </a:effectRef>
-          <a:fontRef idx="minor">
-            <a:schemeClr val="tx1"/>
-          </a:fontRef>
-        </p:style>
-      </p:cxnSp>
-      <p:sp>
-        <p:nvSpPr>
-          <p:cNvPr id="112" name="Rechteck 111">
-            <a:extLst>
-              <a:ext uri="{FF2B5EF4-FFF2-40B4-BE49-F238E27FC236}">
-                <a16:creationId xmlns:a16="http://schemas.microsoft.com/office/drawing/2014/main" id="{7EB2F9D6-9C7F-1D01-EA67-3198FCF752D6}"/>
-              </a:ext>
-            </a:extLst>
-          </p:cNvPr>
-          <p:cNvSpPr/>
-          <p:nvPr/>
-        </p:nvSpPr>
-        <p:spPr>
-          <a:xfrm>
-            <a:off x="1098471" y="2882504"/>
-            <a:ext cx="2696164" cy="3399527"/>
-          </a:xfrm>
-          <a:prstGeom prst="rect">
-            <a:avLst/>
-          </a:prstGeom>
-          <a:noFill/>
-          <a:ln w="38100">
-            <a:solidFill>
-              <a:srgbClr val="FFC000"/>
-            </a:solidFill>
-          </a:ln>
-        </p:spPr>
-        <p:style>
-          <a:lnRef idx="2">
-            <a:schemeClr val="accent1">
-              <a:shade val="15000"/>
-            </a:schemeClr>
-          </a:lnRef>
-          <a:fillRef idx="1">
-            <a:schemeClr val="accent1"/>
-          </a:fillRef>
-          <a:effectRef idx="0">
-            <a:schemeClr val="accent1"/>
-          </a:effectRef>
-          <a:fontRef idx="minor">
-            <a:schemeClr val="lt1"/>
-          </a:fontRef>
-        </p:style>
-        <p:txBody>
-          <a:bodyPr rtlCol="0" anchor="ctr"/>
-          <a:lstStyle/>
-          <a:p>
-            <a:pPr algn="ctr"/>
-            <a:endParaRPr lang="de-DE"/>
-          </a:p>
-        </p:txBody>
-      </p:sp>
-      <p:sp>
-        <p:nvSpPr>
-          <p:cNvPr id="114" name="Textfeld 113">
-            <a:extLst>
-              <a:ext uri="{FF2B5EF4-FFF2-40B4-BE49-F238E27FC236}">
-                <a16:creationId xmlns:a16="http://schemas.microsoft.com/office/drawing/2014/main" id="{A5168879-19E2-54CC-3CB2-5F19460B8FFD}"/>
-              </a:ext>
-            </a:extLst>
-          </p:cNvPr>
-          <p:cNvSpPr txBox="1"/>
-          <p:nvPr/>
-        </p:nvSpPr>
-        <p:spPr>
-          <a:xfrm>
-            <a:off x="5948113" y="2571347"/>
-            <a:ext cx="1986965" cy="600164"/>
-          </a:xfrm>
-          <a:prstGeom prst="rect">
-            <a:avLst/>
-          </a:prstGeom>
-          <a:noFill/>
-          <a:ln>
-            <a:solidFill>
-              <a:schemeClr val="tx1"/>
-            </a:solidFill>
-            <a:prstDash val="dash"/>
-          </a:ln>
-        </p:spPr>
-        <p:txBody>
-          <a:bodyPr wrap="square" rtlCol="0">
-            <a:spAutoFit/>
-          </a:bodyPr>
-          <a:lstStyle/>
-          <a:p>
-            <a:r>
-              <a:rPr lang="de-DE" sz="1100" b="1" dirty="0">
-                <a:solidFill>
-                  <a:srgbClr val="C00000"/>
-                </a:solidFill>
-              </a:rPr>
-              <a:t>Daten-Gewichtsabgleich: </a:t>
-            </a:r>
-          </a:p>
-          <a:p>
-            <a:r>
-              <a:rPr lang="de-DE" sz="1100" dirty="0">
-                <a:solidFill>
-                  <a:srgbClr val="C00000"/>
-                </a:solidFill>
-              </a:rPr>
-              <a:t>a) Gewicht der Waage mit</a:t>
-            </a:r>
-          </a:p>
-          <a:p>
-            <a:r>
-              <a:rPr lang="de-DE" sz="1100" dirty="0">
-                <a:solidFill>
-                  <a:srgbClr val="C00000"/>
-                </a:solidFill>
-              </a:rPr>
-              <a:t>b) theoretischem Gewicht</a:t>
-            </a:r>
-          </a:p>
-        </p:txBody>
-      </p:sp>
-      <p:sp>
-        <p:nvSpPr>
-          <p:cNvPr id="94" name="Textfeld 93">
-            <a:extLst>
-              <a:ext uri="{FF2B5EF4-FFF2-40B4-BE49-F238E27FC236}">
-                <a16:creationId xmlns:a16="http://schemas.microsoft.com/office/drawing/2014/main" id="{51215F56-0A42-6FE8-EBD4-5588CB7764ED}"/>
-              </a:ext>
-            </a:extLst>
-          </p:cNvPr>
-          <p:cNvSpPr txBox="1"/>
-          <p:nvPr/>
-        </p:nvSpPr>
-        <p:spPr>
-          <a:xfrm>
-            <a:off x="4648522" y="1805750"/>
-            <a:ext cx="1636122" cy="246221"/>
-          </a:xfrm>
-          <a:prstGeom prst="rect">
-            <a:avLst/>
-          </a:prstGeom>
-          <a:noFill/>
-        </p:spPr>
-        <p:txBody>
-          <a:bodyPr wrap="square" rtlCol="0">
-            <a:spAutoFit/>
-          </a:bodyPr>
-          <a:lstStyle/>
-          <a:p>
-            <a:r>
-              <a:rPr lang="de-DE" sz="1000" b="1" dirty="0"/>
-              <a:t>Labelmaschine</a:t>
-            </a:r>
-          </a:p>
-        </p:txBody>
-      </p:sp>
-      <p:cxnSp>
-        <p:nvCxnSpPr>
-          <p:cNvPr id="117" name="Gerade Verbindung mit Pfeil 116">
-            <a:extLst>
-              <a:ext uri="{FF2B5EF4-FFF2-40B4-BE49-F238E27FC236}">
-                <a16:creationId xmlns:a16="http://schemas.microsoft.com/office/drawing/2014/main" id="{327C7C8B-D99E-17D1-8A24-2C6F3863996D}"/>
-              </a:ext>
-            </a:extLst>
-          </p:cNvPr>
-          <p:cNvCxnSpPr>
-            <a:cxnSpLocks/>
-          </p:cNvCxnSpPr>
-          <p:nvPr/>
-        </p:nvCxnSpPr>
-        <p:spPr>
-          <a:xfrm flipH="1" flipV="1">
-            <a:off x="7837336" y="2931276"/>
-            <a:ext cx="557409" cy="644273"/>
-          </a:xfrm>
-          <a:prstGeom prst="straightConnector1">
-            <a:avLst/>
-          </a:prstGeom>
-          <a:ln w="28575">
-            <a:solidFill>
-              <a:srgbClr val="C00000"/>
-            </a:solidFill>
-            <a:tailEnd type="triangle"/>
-          </a:ln>
-        </p:spPr>
-        <p:style>
-          <a:lnRef idx="2">
-            <a:schemeClr val="accent1"/>
-          </a:lnRef>
-          <a:fillRef idx="0">
-            <a:schemeClr val="accent1"/>
-          </a:fillRef>
-          <a:effectRef idx="1">
-            <a:schemeClr val="accent1"/>
-          </a:effectRef>
-          <a:fontRef idx="minor">
-            <a:schemeClr val="tx1"/>
-          </a:fontRef>
-        </p:style>
-      </p:cxnSp>
-      <p:sp>
-        <p:nvSpPr>
-          <p:cNvPr id="120" name="Textfeld 119">
-            <a:extLst>
-              <a:ext uri="{FF2B5EF4-FFF2-40B4-BE49-F238E27FC236}">
-                <a16:creationId xmlns:a16="http://schemas.microsoft.com/office/drawing/2014/main" id="{40711243-D7AE-99CC-6970-230E07EFC132}"/>
-              </a:ext>
-            </a:extLst>
-          </p:cNvPr>
-          <p:cNvSpPr txBox="1"/>
-          <p:nvPr/>
-        </p:nvSpPr>
-        <p:spPr>
-          <a:xfrm rot="2923852">
-            <a:off x="7681705" y="3135636"/>
-            <a:ext cx="1156333" cy="246221"/>
-          </a:xfrm>
-          <a:prstGeom prst="rect">
-            <a:avLst/>
-          </a:prstGeom>
-          <a:noFill/>
-        </p:spPr>
-        <p:txBody>
-          <a:bodyPr wrap="square" rtlCol="0">
-            <a:spAutoFit/>
-          </a:bodyPr>
-          <a:lstStyle/>
-          <a:p>
-            <a:r>
-              <a:rPr lang="de-DE" sz="1000" i="1" dirty="0"/>
-              <a:t>Kommunikation</a:t>
-            </a:r>
-          </a:p>
-        </p:txBody>
-      </p:sp>
-      <p:sp>
-        <p:nvSpPr>
-          <p:cNvPr id="126" name="Ellipse 125">
-            <a:extLst>
-              <a:ext uri="{FF2B5EF4-FFF2-40B4-BE49-F238E27FC236}">
-                <a16:creationId xmlns:a16="http://schemas.microsoft.com/office/drawing/2014/main" id="{E084A15F-493E-7B1A-795C-56DC12BF3884}"/>
-              </a:ext>
-            </a:extLst>
-          </p:cNvPr>
-          <p:cNvSpPr/>
-          <p:nvPr/>
-        </p:nvSpPr>
-        <p:spPr>
-          <a:xfrm>
-            <a:off x="7447524" y="1891171"/>
-            <a:ext cx="676351" cy="664624"/>
-          </a:xfrm>
-          <a:prstGeom prst="ellipse">
-            <a:avLst/>
-          </a:prstGeom>
-          <a:noFill/>
-        </p:spPr>
-        <p:style>
-          <a:lnRef idx="2">
-            <a:schemeClr val="accent1">
-              <a:shade val="15000"/>
-            </a:schemeClr>
-          </a:lnRef>
-          <a:fillRef idx="1">
-            <a:schemeClr val="accent1"/>
-          </a:fillRef>
-          <a:effectRef idx="0">
-            <a:schemeClr val="accent1"/>
-          </a:effectRef>
-          <a:fontRef idx="minor">
-            <a:schemeClr val="lt1"/>
-          </a:fontRef>
-        </p:style>
-        <p:txBody>
-          <a:bodyPr rtlCol="0" anchor="ctr"/>
-          <a:lstStyle/>
-          <a:p>
-            <a:pPr algn="ctr"/>
-            <a:endParaRPr lang="de-DE"/>
-          </a:p>
-        </p:txBody>
-      </p:sp>
-      <p:sp>
-        <p:nvSpPr>
-          <p:cNvPr id="133" name="Textfeld 132">
-            <a:extLst>
-              <a:ext uri="{FF2B5EF4-FFF2-40B4-BE49-F238E27FC236}">
-                <a16:creationId xmlns:a16="http://schemas.microsoft.com/office/drawing/2014/main" id="{5FC271D4-11D3-BBEE-D417-B21E580D6DCB}"/>
-              </a:ext>
-            </a:extLst>
-          </p:cNvPr>
-          <p:cNvSpPr txBox="1"/>
-          <p:nvPr/>
-        </p:nvSpPr>
-        <p:spPr>
-          <a:xfrm>
-            <a:off x="1715334" y="2867732"/>
-            <a:ext cx="1495321" cy="430887"/>
-          </a:xfrm>
-          <a:prstGeom prst="rect">
-            <a:avLst/>
-          </a:prstGeom>
-          <a:noFill/>
-        </p:spPr>
-        <p:txBody>
-          <a:bodyPr wrap="square" rtlCol="0">
-            <a:spAutoFit/>
-          </a:bodyPr>
-          <a:lstStyle/>
-          <a:p>
-            <a:pPr algn="ctr"/>
-            <a:r>
-              <a:rPr lang="de-DE" sz="1100" dirty="0">
-                <a:solidFill>
-                  <a:srgbClr val="C00000"/>
-                </a:solidFill>
-              </a:rPr>
-              <a:t>Gewichtsdifferenz </a:t>
-            </a:r>
-          </a:p>
-          <a:p>
-            <a:pPr algn="ctr"/>
-            <a:r>
-              <a:rPr lang="de-DE" sz="1100" dirty="0">
-                <a:solidFill>
-                  <a:srgbClr val="C00000"/>
-                </a:solidFill>
-              </a:rPr>
-              <a:t>passt </a:t>
-            </a:r>
-            <a:r>
-              <a:rPr lang="de-DE" sz="1100" b="1" dirty="0">
-                <a:solidFill>
-                  <a:srgbClr val="C00000"/>
-                </a:solidFill>
-              </a:rPr>
-              <a:t>NICHT</a:t>
-            </a:r>
-          </a:p>
-        </p:txBody>
-      </p:sp>
-      <p:cxnSp>
-        <p:nvCxnSpPr>
-          <p:cNvPr id="142" name="Gerade Verbindung mit Pfeil 141">
-            <a:extLst>
-              <a:ext uri="{FF2B5EF4-FFF2-40B4-BE49-F238E27FC236}">
-                <a16:creationId xmlns:a16="http://schemas.microsoft.com/office/drawing/2014/main" id="{9A56873B-3CA9-7DB1-FB54-1D01BC50A117}"/>
-              </a:ext>
-            </a:extLst>
-          </p:cNvPr>
-          <p:cNvCxnSpPr>
-            <a:cxnSpLocks/>
-          </p:cNvCxnSpPr>
-          <p:nvPr/>
-        </p:nvCxnSpPr>
-        <p:spPr>
-          <a:xfrm flipH="1" flipV="1">
-            <a:off x="681699" y="2607411"/>
-            <a:ext cx="1588513" cy="0"/>
-          </a:xfrm>
-          <a:prstGeom prst="straightConnector1">
-            <a:avLst/>
-          </a:prstGeom>
-          <a:ln w="22225">
-            <a:solidFill>
-              <a:srgbClr val="00FF00"/>
-            </a:solidFill>
-            <a:prstDash val="dash"/>
-            <a:tailEnd type="triangle"/>
-          </a:ln>
-        </p:spPr>
-        <p:style>
-          <a:lnRef idx="2">
-            <a:schemeClr val="accent1"/>
-          </a:lnRef>
-          <a:fillRef idx="0">
-            <a:schemeClr val="accent1"/>
-          </a:fillRef>
-          <a:effectRef idx="1">
-            <a:schemeClr val="accent1"/>
-          </a:effectRef>
-          <a:fontRef idx="minor">
-            <a:schemeClr val="tx1"/>
-          </a:fontRef>
-        </p:style>
-      </p:cxnSp>
-      <p:sp>
-        <p:nvSpPr>
-          <p:cNvPr id="148" name="Rechteck 147">
-            <a:extLst>
-              <a:ext uri="{FF2B5EF4-FFF2-40B4-BE49-F238E27FC236}">
-                <a16:creationId xmlns:a16="http://schemas.microsoft.com/office/drawing/2014/main" id="{5A3DED2A-C110-D866-1F8E-70B8AB9BBF42}"/>
-              </a:ext>
-            </a:extLst>
-          </p:cNvPr>
-          <p:cNvSpPr/>
-          <p:nvPr/>
-        </p:nvSpPr>
-        <p:spPr>
-          <a:xfrm>
-            <a:off x="5188720" y="3012876"/>
-            <a:ext cx="45719" cy="330352"/>
-          </a:xfrm>
-          <a:prstGeom prst="rect">
-            <a:avLst/>
-          </a:prstGeom>
-          <a:solidFill>
-            <a:schemeClr val="tx1"/>
-          </a:solidFill>
-        </p:spPr>
-        <p:style>
-          <a:lnRef idx="2">
-            <a:schemeClr val="accent1">
-              <a:shade val="15000"/>
-            </a:schemeClr>
-          </a:lnRef>
-          <a:fillRef idx="1">
-            <a:schemeClr val="accent1"/>
-          </a:fillRef>
-          <a:effectRef idx="0">
-            <a:schemeClr val="accent1"/>
-          </a:effectRef>
-          <a:fontRef idx="minor">
-            <a:schemeClr val="lt1"/>
-          </a:fontRef>
-        </p:style>
-        <p:txBody>
-          <a:bodyPr rtlCol="0" anchor="ctr"/>
-          <a:lstStyle/>
-          <a:p>
-            <a:pPr algn="ctr"/>
-            <a:endParaRPr lang="de-DE"/>
-          </a:p>
-        </p:txBody>
-      </p:sp>
-      <p:cxnSp>
-        <p:nvCxnSpPr>
-          <p:cNvPr id="153" name="Gerade Verbindung mit Pfeil 152">
-            <a:extLst>
-              <a:ext uri="{FF2B5EF4-FFF2-40B4-BE49-F238E27FC236}">
-                <a16:creationId xmlns:a16="http://schemas.microsoft.com/office/drawing/2014/main" id="{C2DA8E77-2CF2-DF88-4916-F925A9C6FEF5}"/>
-              </a:ext>
-            </a:extLst>
-          </p:cNvPr>
-          <p:cNvCxnSpPr>
-            <a:cxnSpLocks/>
-          </p:cNvCxnSpPr>
-          <p:nvPr/>
-        </p:nvCxnSpPr>
-        <p:spPr>
-          <a:xfrm flipH="1">
-            <a:off x="2611840" y="4303748"/>
-            <a:ext cx="462620" cy="41379"/>
-          </a:xfrm>
-          <a:prstGeom prst="straightConnector1">
-            <a:avLst/>
-          </a:prstGeom>
-          <a:ln w="25400">
-            <a:solidFill>
-              <a:schemeClr val="bg2"/>
-            </a:solidFill>
-            <a:prstDash val="sysDot"/>
-            <a:tailEnd type="triangle"/>
-          </a:ln>
-        </p:spPr>
-        <p:style>
-          <a:lnRef idx="2">
-            <a:schemeClr val="accent1"/>
-          </a:lnRef>
-          <a:fillRef idx="0">
-            <a:schemeClr val="accent1"/>
-          </a:fillRef>
-          <a:effectRef idx="1">
-            <a:schemeClr val="accent1"/>
-          </a:effectRef>
-          <a:fontRef idx="minor">
-            <a:schemeClr val="tx1"/>
-          </a:fontRef>
-        </p:style>
-      </p:cxnSp>
-      <p:cxnSp>
-        <p:nvCxnSpPr>
-          <p:cNvPr id="154" name="Gerade Verbindung mit Pfeil 153">
-            <a:extLst>
-              <a:ext uri="{FF2B5EF4-FFF2-40B4-BE49-F238E27FC236}">
-                <a16:creationId xmlns:a16="http://schemas.microsoft.com/office/drawing/2014/main" id="{5FB93B3F-0F30-AB52-B330-80CF4A7B50AF}"/>
-              </a:ext>
-            </a:extLst>
-          </p:cNvPr>
-          <p:cNvCxnSpPr>
-            <a:cxnSpLocks/>
-          </p:cNvCxnSpPr>
-          <p:nvPr/>
-        </p:nvCxnSpPr>
-        <p:spPr>
-          <a:xfrm flipH="1">
-            <a:off x="3574846" y="4206063"/>
-            <a:ext cx="462620" cy="41379"/>
-          </a:xfrm>
-          <a:prstGeom prst="straightConnector1">
-            <a:avLst/>
-          </a:prstGeom>
-          <a:ln w="25400">
-            <a:solidFill>
-              <a:schemeClr val="bg2"/>
-            </a:solidFill>
-            <a:prstDash val="sysDot"/>
-            <a:tailEnd type="triangle"/>
-          </a:ln>
-        </p:spPr>
-        <p:style>
-          <a:lnRef idx="2">
-            <a:schemeClr val="accent1"/>
-          </a:lnRef>
-          <a:fillRef idx="0">
-            <a:schemeClr val="accent1"/>
-          </a:fillRef>
-          <a:effectRef idx="1">
-            <a:schemeClr val="accent1"/>
-          </a:effectRef>
-          <a:fontRef idx="minor">
-            <a:schemeClr val="tx1"/>
-          </a:fontRef>
-        </p:style>
-      </p:cxnSp>
-      <p:cxnSp>
-        <p:nvCxnSpPr>
-          <p:cNvPr id="156" name="Gerade Verbindung mit Pfeil 155">
-            <a:extLst>
-              <a:ext uri="{FF2B5EF4-FFF2-40B4-BE49-F238E27FC236}">
-                <a16:creationId xmlns:a16="http://schemas.microsoft.com/office/drawing/2014/main" id="{FF7B35A2-5509-3879-585E-C88B62323F87}"/>
-              </a:ext>
-            </a:extLst>
-          </p:cNvPr>
-          <p:cNvCxnSpPr>
-            <a:cxnSpLocks/>
-          </p:cNvCxnSpPr>
-          <p:nvPr/>
-        </p:nvCxnSpPr>
-        <p:spPr>
-          <a:xfrm>
-            <a:off x="2321230" y="2616654"/>
-            <a:ext cx="0" cy="274191"/>
-          </a:xfrm>
-          <a:prstGeom prst="straightConnector1">
-            <a:avLst/>
-          </a:prstGeom>
-          <a:ln w="22225">
-            <a:solidFill>
-              <a:srgbClr val="C00000"/>
-            </a:solidFill>
-            <a:prstDash val="dash"/>
-            <a:tailEnd type="triangle"/>
-          </a:ln>
-        </p:spPr>
-        <p:style>
-          <a:lnRef idx="2">
-            <a:schemeClr val="accent1"/>
-          </a:lnRef>
-          <a:fillRef idx="0">
-            <a:schemeClr val="accent1"/>
-          </a:fillRef>
-          <a:effectRef idx="1">
-            <a:schemeClr val="accent1"/>
-          </a:effectRef>
-          <a:fontRef idx="minor">
-            <a:schemeClr val="tx1"/>
-          </a:fontRef>
-        </p:style>
-      </p:cxnSp>
-      <p:cxnSp>
-        <p:nvCxnSpPr>
-          <p:cNvPr id="163" name="Gerade Verbindung mit Pfeil 162">
-            <a:extLst>
-              <a:ext uri="{FF2B5EF4-FFF2-40B4-BE49-F238E27FC236}">
-                <a16:creationId xmlns:a16="http://schemas.microsoft.com/office/drawing/2014/main" id="{ADF44A1B-41F2-6042-F0FB-002F7B938C24}"/>
-              </a:ext>
-            </a:extLst>
-          </p:cNvPr>
-          <p:cNvCxnSpPr>
-            <a:cxnSpLocks/>
-          </p:cNvCxnSpPr>
-          <p:nvPr/>
-        </p:nvCxnSpPr>
-        <p:spPr>
-          <a:xfrm flipH="1" flipV="1">
-            <a:off x="5633709" y="2621670"/>
-            <a:ext cx="323929" cy="240234"/>
-          </a:xfrm>
-          <a:prstGeom prst="straightConnector1">
-            <a:avLst/>
-          </a:prstGeom>
-          <a:ln w="22225">
-            <a:solidFill>
-              <a:schemeClr val="tx1"/>
-            </a:solidFill>
-            <a:prstDash val="dash"/>
-            <a:tailEnd type="none"/>
-          </a:ln>
-        </p:spPr>
-        <p:style>
-          <a:lnRef idx="2">
-            <a:schemeClr val="accent1"/>
-          </a:lnRef>
-          <a:fillRef idx="0">
-            <a:schemeClr val="accent1"/>
-          </a:fillRef>
-          <a:effectRef idx="1">
-            <a:schemeClr val="accent1"/>
-          </a:effectRef>
-          <a:fontRef idx="minor">
-            <a:schemeClr val="tx1"/>
-          </a:fontRef>
-        </p:style>
-      </p:cxnSp>
-      <p:pic>
-        <p:nvPicPr>
-          <p:cNvPr id="2" name="Grafik 1">
-            <a:extLst>
-              <a:ext uri="{FF2B5EF4-FFF2-40B4-BE49-F238E27FC236}">
-                <a16:creationId xmlns:a16="http://schemas.microsoft.com/office/drawing/2014/main" id="{D9BA12D6-1956-4452-83F2-8A41E822AAC9}"/>
-              </a:ext>
-            </a:extLst>
-          </p:cNvPr>
-          <p:cNvPicPr>
-            <a:picLocks noChangeAspect="1"/>
-          </p:cNvPicPr>
-          <p:nvPr/>
-        </p:nvPicPr>
-        <p:blipFill>
-          <a:blip r:embed="rId3"/>
-          <a:stretch>
-            <a:fillRect/>
-          </a:stretch>
-        </p:blipFill>
-        <p:spPr>
-          <a:xfrm>
-            <a:off x="2951808" y="4782651"/>
-            <a:ext cx="795747" cy="616194"/>
-          </a:xfrm>
-          <a:prstGeom prst="rect">
-            <a:avLst/>
-          </a:prstGeom>
-        </p:spPr>
-      </p:pic>
-    </p:spTree>
-    <p:extLst>
-      <p:ext uri="{BB962C8B-B14F-4D97-AF65-F5344CB8AC3E}">
-        <p14:creationId xmlns:p14="http://schemas.microsoft.com/office/powerpoint/2010/main" val="359237405"/>
-      </p:ext>
-    </p:extLst>
-  </p:cSld>
-  <p:clrMapOvr>
-    <a:masterClrMapping/>
-  </p:clrMapOvr>
-</p:sld>
-</file>
-
-<file path=ppt/slides/slide3.xml><?xml version="1.0" encoding="utf-8"?>
-<p:sld xmlns:a="http://schemas.openxmlformats.org/drawingml/2006/main" xmlns:r="http://schemas.openxmlformats.org/officeDocument/2006/relationships" xmlns:p="http://schemas.openxmlformats.org/presentationml/2006/main">
-  <p:cSld>
-    <p:spTree>
-      <p:nvGrpSpPr>
-        <p:cNvPr id="1" name=""/>
-        <p:cNvGrpSpPr/>
-        <p:nvPr/>
-      </p:nvGrpSpPr>
-      <p:grpSpPr>
-        <a:xfrm>
-          <a:off x="0" y="0"/>
-          <a:ext cx="0" cy="0"/>
-          <a:chOff x="0" y="0"/>
-          <a:chExt cx="0" cy="0"/>
-        </a:xfrm>
-      </p:grpSpPr>
-      <p:pic>
-        <p:nvPicPr>
-          <p:cNvPr id="3" name="Grafik 2">
-            <a:extLst>
-              <a:ext uri="{FF2B5EF4-FFF2-40B4-BE49-F238E27FC236}">
-                <a16:creationId xmlns:a16="http://schemas.microsoft.com/office/drawing/2014/main" id="{E876A137-CCC9-FF29-6B0E-23AA52B33828}"/>
-              </a:ext>
-            </a:extLst>
-          </p:cNvPr>
-          <p:cNvPicPr>
-            <a:picLocks noChangeAspect="1"/>
-          </p:cNvPicPr>
-          <p:nvPr/>
-        </p:nvPicPr>
-        <p:blipFill>
-          <a:blip r:embed="rId2"/>
-          <a:stretch>
-            <a:fillRect/>
-          </a:stretch>
-        </p:blipFill>
-        <p:spPr>
-          <a:xfrm>
-            <a:off x="1371600" y="1570308"/>
-            <a:ext cx="9264770" cy="4109690"/>
+            <a:off x="437072" y="2572115"/>
+            <a:ext cx="11260347" cy="1238209"/>
           </a:xfrm>
           <a:prstGeom prst="rect">
             <a:avLst/>
@@ -6271,374 +4003,12 @@
             <a:noFill/>
           </a:ln>
           <a:effectLst>
-            <a:softEdge rad="112500"/>
+            <a:outerShdw blurRad="292100" dist="139700" dir="2700000" algn="tl" rotWithShape="0">
+              <a:srgbClr val="333333">
+                <a:alpha val="65000"/>
+              </a:srgbClr>
+            </a:outerShdw>
           </a:effectLst>
-        </p:spPr>
-      </p:pic>
-      <p:sp>
-        <p:nvSpPr>
-          <p:cNvPr id="4" name="Textfeld 3">
-            <a:extLst>
-              <a:ext uri="{FF2B5EF4-FFF2-40B4-BE49-F238E27FC236}">
-                <a16:creationId xmlns:a16="http://schemas.microsoft.com/office/drawing/2014/main" id="{5BD589FB-3D50-CF9F-390B-9D2AE3367237}"/>
-              </a:ext>
-            </a:extLst>
-          </p:cNvPr>
-          <p:cNvSpPr txBox="1"/>
-          <p:nvPr/>
-        </p:nvSpPr>
-        <p:spPr>
-          <a:xfrm>
-            <a:off x="1371600" y="910583"/>
-            <a:ext cx="6991928" cy="584775"/>
-          </a:xfrm>
-          <a:prstGeom prst="rect">
-            <a:avLst/>
-          </a:prstGeom>
-          <a:noFill/>
-        </p:spPr>
-        <p:txBody>
-          <a:bodyPr wrap="square" rtlCol="0">
-            <a:spAutoFit/>
-          </a:bodyPr>
-          <a:lstStyle/>
-          <a:p>
-            <a:r>
-              <a:rPr lang="de-DE" sz="3200" dirty="0"/>
-              <a:t>Wie sieht so ein Logfile aus?</a:t>
-            </a:r>
-          </a:p>
-        </p:txBody>
-      </p:sp>
-      <p:sp>
-        <p:nvSpPr>
-          <p:cNvPr id="5" name="Textfeld 4">
-            <a:extLst>
-              <a:ext uri="{FF2B5EF4-FFF2-40B4-BE49-F238E27FC236}">
-                <a16:creationId xmlns:a16="http://schemas.microsoft.com/office/drawing/2014/main" id="{96F11A2E-8948-FEC7-CB94-3BF3E8A8BA54}"/>
-              </a:ext>
-            </a:extLst>
-          </p:cNvPr>
-          <p:cNvSpPr txBox="1"/>
-          <p:nvPr/>
-        </p:nvSpPr>
-        <p:spPr>
-          <a:xfrm rot="20058608">
-            <a:off x="2687398" y="2811614"/>
-            <a:ext cx="5851944" cy="954107"/>
-          </a:xfrm>
-          <a:prstGeom prst="rect">
-            <a:avLst/>
-          </a:prstGeom>
-          <a:noFill/>
-        </p:spPr>
-        <p:txBody>
-          <a:bodyPr wrap="square" rtlCol="0">
-            <a:spAutoFit/>
-          </a:bodyPr>
-          <a:lstStyle/>
-          <a:p>
-            <a:r>
-              <a:rPr lang="de-DE" sz="2800" b="1" dirty="0">
-                <a:solidFill>
-                  <a:srgbClr val="C00000"/>
-                </a:solidFill>
-              </a:rPr>
-              <a:t>Ca. 5.000 Pakete erzeugen </a:t>
-            </a:r>
-          </a:p>
-          <a:p>
-            <a:r>
-              <a:rPr lang="de-DE" sz="2800" b="1" dirty="0">
-                <a:solidFill>
-                  <a:srgbClr val="C00000"/>
-                </a:solidFill>
-              </a:rPr>
-              <a:t>innerhalb 24h ca. 15k – 20k Zeilen</a:t>
-            </a:r>
-          </a:p>
-        </p:txBody>
-      </p:sp>
-      <p:sp>
-        <p:nvSpPr>
-          <p:cNvPr id="6" name="Pfeil: nach unten 5">
-            <a:extLst>
-              <a:ext uri="{FF2B5EF4-FFF2-40B4-BE49-F238E27FC236}">
-                <a16:creationId xmlns:a16="http://schemas.microsoft.com/office/drawing/2014/main" id="{437208F2-8657-D544-C3CA-90436DA056AA}"/>
-              </a:ext>
-            </a:extLst>
-          </p:cNvPr>
-          <p:cNvSpPr/>
-          <p:nvPr/>
-        </p:nvSpPr>
-        <p:spPr>
-          <a:xfrm rot="16200000">
-            <a:off x="11472725" y="6153493"/>
-            <a:ext cx="429545" cy="528032"/>
-          </a:xfrm>
-          <a:prstGeom prst="downArrow">
-            <a:avLst/>
-          </a:prstGeom>
-        </p:spPr>
-        <p:style>
-          <a:lnRef idx="2">
-            <a:schemeClr val="accent6">
-              <a:shade val="15000"/>
-            </a:schemeClr>
-          </a:lnRef>
-          <a:fillRef idx="1">
-            <a:schemeClr val="accent6"/>
-          </a:fillRef>
-          <a:effectRef idx="0">
-            <a:schemeClr val="accent6"/>
-          </a:effectRef>
-          <a:fontRef idx="minor">
-            <a:schemeClr val="lt1"/>
-          </a:fontRef>
-        </p:style>
-        <p:txBody>
-          <a:bodyPr rtlCol="0" anchor="ctr"/>
-          <a:lstStyle/>
-          <a:p>
-            <a:pPr algn="ctr"/>
-            <a:endParaRPr lang="de-DE"/>
-          </a:p>
-        </p:txBody>
-      </p:sp>
-      <p:pic>
-        <p:nvPicPr>
-          <p:cNvPr id="7" name="Grafik 6" descr="Lupe mit einfarbiger Füllung">
-            <a:extLst>
-              <a:ext uri="{FF2B5EF4-FFF2-40B4-BE49-F238E27FC236}">
-                <a16:creationId xmlns:a16="http://schemas.microsoft.com/office/drawing/2014/main" id="{B262D8B7-19D6-BD0A-B50C-3105D0B7814C}"/>
-              </a:ext>
-            </a:extLst>
-          </p:cNvPr>
-          <p:cNvPicPr>
-            <a:picLocks noChangeAspect="1"/>
-          </p:cNvPicPr>
-          <p:nvPr/>
-        </p:nvPicPr>
-        <p:blipFill>
-          <a:blip r:embed="rId3">
-            <a:extLst>
-              <a:ext uri="{96DAC541-7B7A-43D3-8B79-37D633B846F1}">
-                <asvg:svgBlip xmlns:asvg="http://schemas.microsoft.com/office/drawing/2016/SVG/main" r:embed="rId4"/>
-              </a:ext>
-            </a:extLst>
-          </a:blip>
-          <a:stretch>
-            <a:fillRect/>
-          </a:stretch>
-        </p:blipFill>
-        <p:spPr>
-          <a:xfrm flipH="1">
-            <a:off x="10966169" y="6254092"/>
-            <a:ext cx="440888" cy="429547"/>
-          </a:xfrm>
-          <a:prstGeom prst="rect">
-            <a:avLst/>
-          </a:prstGeom>
-        </p:spPr>
-      </p:pic>
-      <p:sp>
-        <p:nvSpPr>
-          <p:cNvPr id="8" name="Additionszeichen 7">
-            <a:extLst>
-              <a:ext uri="{FF2B5EF4-FFF2-40B4-BE49-F238E27FC236}">
-                <a16:creationId xmlns:a16="http://schemas.microsoft.com/office/drawing/2014/main" id="{826D59E6-C400-C675-7432-90B58024D615}"/>
-              </a:ext>
-            </a:extLst>
-          </p:cNvPr>
-          <p:cNvSpPr/>
-          <p:nvPr/>
-        </p:nvSpPr>
-        <p:spPr>
-          <a:xfrm>
-            <a:off x="11152085" y="6332758"/>
-            <a:ext cx="122952" cy="174956"/>
-          </a:xfrm>
-          <a:prstGeom prst="mathPlus">
-            <a:avLst/>
-          </a:prstGeom>
-          <a:ln w="0"/>
-        </p:spPr>
-        <p:style>
-          <a:lnRef idx="2">
-            <a:schemeClr val="dk1">
-              <a:shade val="15000"/>
-            </a:schemeClr>
-          </a:lnRef>
-          <a:fillRef idx="1">
-            <a:schemeClr val="dk1"/>
-          </a:fillRef>
-          <a:effectRef idx="0">
-            <a:schemeClr val="dk1"/>
-          </a:effectRef>
-          <a:fontRef idx="minor">
-            <a:schemeClr val="lt1"/>
-          </a:fontRef>
-        </p:style>
-        <p:txBody>
-          <a:bodyPr rtlCol="0" anchor="ctr"/>
-          <a:lstStyle/>
-          <a:p>
-            <a:pPr algn="ctr"/>
-            <a:endParaRPr lang="de-DE"/>
-          </a:p>
-        </p:txBody>
-      </p:sp>
-      <p:sp>
-        <p:nvSpPr>
-          <p:cNvPr id="10" name="Textfeld 9">
-            <a:extLst>
-              <a:ext uri="{FF2B5EF4-FFF2-40B4-BE49-F238E27FC236}">
-                <a16:creationId xmlns:a16="http://schemas.microsoft.com/office/drawing/2014/main" id="{B559544C-04CC-B1CC-E21A-2D30087AF21A}"/>
-              </a:ext>
-            </a:extLst>
-          </p:cNvPr>
-          <p:cNvSpPr txBox="1"/>
-          <p:nvPr/>
-        </p:nvSpPr>
-        <p:spPr>
-          <a:xfrm>
-            <a:off x="4533612" y="6615225"/>
-            <a:ext cx="7158502" cy="215444"/>
-          </a:xfrm>
-          <a:prstGeom prst="rect">
-            <a:avLst/>
-          </a:prstGeom>
-          <a:noFill/>
-        </p:spPr>
-        <p:txBody>
-          <a:bodyPr wrap="square">
-            <a:spAutoFit/>
-          </a:bodyPr>
-          <a:lstStyle/>
-          <a:p>
-            <a:pPr algn="r"/>
-            <a:r>
-              <a:rPr lang="de-DE" sz="800" dirty="0">
-                <a:solidFill>
-                  <a:srgbClr val="FF0000"/>
-                </a:solidFill>
-              </a:rPr>
-              <a:t>Logfile wurde anhand eines eigenen Logfile-Generators verwendet, der verschiedene Real-Life Situationen  generiert</a:t>
-            </a:r>
-          </a:p>
-        </p:txBody>
-      </p:sp>
-    </p:spTree>
-    <p:extLst>
-      <p:ext uri="{BB962C8B-B14F-4D97-AF65-F5344CB8AC3E}">
-        <p14:creationId xmlns:p14="http://schemas.microsoft.com/office/powerpoint/2010/main" val="3243030485"/>
-      </p:ext>
-    </p:extLst>
-  </p:cSld>
-  <p:clrMapOvr>
-    <a:masterClrMapping/>
-  </p:clrMapOvr>
-</p:sld>
-</file>
-
-<file path=ppt/slides/slide4.xml><?xml version="1.0" encoding="utf-8"?>
-<p:sld xmlns:a="http://schemas.openxmlformats.org/drawingml/2006/main" xmlns:r="http://schemas.openxmlformats.org/officeDocument/2006/relationships" xmlns:p="http://schemas.openxmlformats.org/presentationml/2006/main">
-  <p:cSld>
-    <p:spTree>
-      <p:nvGrpSpPr>
-        <p:cNvPr id="1" name=""/>
-        <p:cNvGrpSpPr/>
-        <p:nvPr/>
-      </p:nvGrpSpPr>
-      <p:grpSpPr>
-        <a:xfrm>
-          <a:off x="0" y="0"/>
-          <a:ext cx="0" cy="0"/>
-          <a:chOff x="0" y="0"/>
-          <a:chExt cx="0" cy="0"/>
-        </a:xfrm>
-      </p:grpSpPr>
-      <p:sp>
-        <p:nvSpPr>
-          <p:cNvPr id="2" name="Titel 1">
-            <a:extLst>
-              <a:ext uri="{FF2B5EF4-FFF2-40B4-BE49-F238E27FC236}">
-                <a16:creationId xmlns:a16="http://schemas.microsoft.com/office/drawing/2014/main" id="{AF5DA710-7168-EB00-79B6-37454B75FF5C}"/>
-              </a:ext>
-            </a:extLst>
-          </p:cNvPr>
-          <p:cNvSpPr>
-            <a:spLocks noGrp="1"/>
-          </p:cNvSpPr>
-          <p:nvPr>
-            <p:ph type="title"/>
-          </p:nvPr>
-        </p:nvSpPr>
-        <p:spPr>
-          <a:xfrm>
-            <a:off x="437072" y="277771"/>
-            <a:ext cx="10515600" cy="1325563"/>
-          </a:xfrm>
-        </p:spPr>
-        <p:txBody>
-          <a:bodyPr/>
-          <a:lstStyle/>
-          <a:p>
-            <a:r>
-              <a:rPr lang="de-DE" sz="2800" b="1" dirty="0">
-                <a:solidFill>
-                  <a:schemeClr val="bg1"/>
-                </a:solidFill>
-                <a:highlight>
-                  <a:srgbClr val="008000"/>
-                </a:highlight>
-              </a:rPr>
-              <a:t>Projekt-Basis</a:t>
-            </a:r>
-            <a:r>
-              <a:rPr lang="de-DE" dirty="0"/>
-              <a:t>        Insight </a:t>
-            </a:r>
-            <a:r>
-              <a:rPr lang="de-DE" dirty="0">
-                <a:highlight>
-                  <a:srgbClr val="00FF00"/>
-                </a:highlight>
-              </a:rPr>
-              <a:t>Log-Data</a:t>
-            </a:r>
-            <a:endParaRPr lang="de-DE" sz="1100" dirty="0"/>
-          </a:p>
-        </p:txBody>
-      </p:sp>
-      <p:pic>
-        <p:nvPicPr>
-          <p:cNvPr id="4" name="Grafik 3">
-            <a:extLst>
-              <a:ext uri="{FF2B5EF4-FFF2-40B4-BE49-F238E27FC236}">
-                <a16:creationId xmlns:a16="http://schemas.microsoft.com/office/drawing/2014/main" id="{DB5B1C7A-542E-D029-CEB3-F2F7C8509450}"/>
-              </a:ext>
-            </a:extLst>
-          </p:cNvPr>
-          <p:cNvPicPr>
-            <a:picLocks noChangeAspect="1"/>
-          </p:cNvPicPr>
-          <p:nvPr/>
-        </p:nvPicPr>
-        <p:blipFill>
-          <a:blip r:embed="rId2"/>
-          <a:stretch>
-            <a:fillRect/>
-          </a:stretch>
-        </p:blipFill>
-        <p:spPr>
-          <a:xfrm>
-            <a:off x="437072" y="2572115"/>
-            <a:ext cx="11260347" cy="1238209"/>
-          </a:xfrm>
-          <a:prstGeom prst="rect">
-            <a:avLst/>
-          </a:prstGeom>
         </p:spPr>
       </p:pic>
       <p:cxnSp>
@@ -8172,49 +5542,6 @@
       </p:sp>
       <p:sp>
         <p:nvSpPr>
-          <p:cNvPr id="3" name="Textfeld 2">
-            <a:extLst>
-              <a:ext uri="{FF2B5EF4-FFF2-40B4-BE49-F238E27FC236}">
-                <a16:creationId xmlns:a16="http://schemas.microsoft.com/office/drawing/2014/main" id="{6D807C81-ACEB-69C7-9172-82C4C9A1075B}"/>
-              </a:ext>
-            </a:extLst>
-          </p:cNvPr>
-          <p:cNvSpPr txBox="1"/>
-          <p:nvPr/>
-        </p:nvSpPr>
-        <p:spPr>
-          <a:xfrm>
-            <a:off x="9376912" y="241941"/>
-            <a:ext cx="2544565" cy="369332"/>
-          </a:xfrm>
-          <a:prstGeom prst="rect">
-            <a:avLst/>
-          </a:prstGeom>
-          <a:noFill/>
-        </p:spPr>
-        <p:txBody>
-          <a:bodyPr wrap="square" rtlCol="0">
-            <a:spAutoFit/>
-          </a:bodyPr>
-          <a:lstStyle/>
-          <a:p>
-            <a:pPr algn="r"/>
-            <a:r>
-              <a:rPr lang="de-DE" dirty="0">
-                <a:solidFill>
-                  <a:schemeClr val="bg1"/>
-                </a:solidFill>
-                <a:highlight>
-                  <a:srgbClr val="000080"/>
-                </a:highlight>
-              </a:rPr>
-              <a:t>Machine-Log-Navigator</a:t>
-            </a:r>
-          </a:p>
-        </p:txBody>
-      </p:sp>
-      <p:sp>
-        <p:nvSpPr>
           <p:cNvPr id="7" name="Textfeld 6">
             <a:extLst>
               <a:ext uri="{FF2B5EF4-FFF2-40B4-BE49-F238E27FC236}">
@@ -8539,46 +5866,6 @@
                 </a:solidFill>
               </a:rPr>
               <a:t>Bezeichnung Leerverpackung</a:t>
-            </a:r>
-          </a:p>
-        </p:txBody>
-      </p:sp>
-      <p:sp>
-        <p:nvSpPr>
-          <p:cNvPr id="6" name="Textfeld 5">
-            <a:extLst>
-              <a:ext uri="{FF2B5EF4-FFF2-40B4-BE49-F238E27FC236}">
-                <a16:creationId xmlns:a16="http://schemas.microsoft.com/office/drawing/2014/main" id="{D02D4728-0D86-1944-BE55-7C374B7FF732}"/>
-              </a:ext>
-            </a:extLst>
-          </p:cNvPr>
-          <p:cNvSpPr txBox="1"/>
-          <p:nvPr/>
-        </p:nvSpPr>
-        <p:spPr>
-          <a:xfrm>
-            <a:off x="2655666" y="6525313"/>
-            <a:ext cx="9501334" cy="276999"/>
-          </a:xfrm>
-          <a:prstGeom prst="rect">
-            <a:avLst/>
-          </a:prstGeom>
-          <a:noFill/>
-        </p:spPr>
-        <p:txBody>
-          <a:bodyPr wrap="square">
-            <a:spAutoFit/>
-          </a:bodyPr>
-          <a:lstStyle/>
-          <a:p>
-            <a:pPr algn="r"/>
-            <a:r>
-              <a:rPr lang="de-DE" sz="1200" dirty="0">
-                <a:solidFill>
-                  <a:srgbClr val="FF0000"/>
-                </a:solidFill>
-              </a:rPr>
-              <a:t>Diese Logfiles wurden/werden anhand eines eigenen Python-Logfile-Generators verwendet, der verschiedene Real-Life Situationen  generiert</a:t>
             </a:r>
           </a:p>
         </p:txBody>

</xml_diff>

<commit_message>
final updated for wordings and insights in almost all pages
</commit_message>
<xml_diff>
--- a/Logfile_CustomerOrder_Generator/Logfile-Generator.pptx
+++ b/Logfile_CustomerOrder_Generator/Logfile-Generator.pptx
@@ -5870,6 +5870,53 @@
           </a:p>
         </p:txBody>
       </p:sp>
+      <p:sp>
+        <p:nvSpPr>
+          <p:cNvPr id="17" name="Rechteck 16">
+            <a:extLst>
+              <a:ext uri="{FF2B5EF4-FFF2-40B4-BE49-F238E27FC236}">
+                <a16:creationId xmlns:a16="http://schemas.microsoft.com/office/drawing/2014/main" id="{3CA7A38B-7BA0-7376-BD12-267653F38B40}"/>
+              </a:ext>
+            </a:extLst>
+          </p:cNvPr>
+          <p:cNvSpPr/>
+          <p:nvPr/>
+        </p:nvSpPr>
+        <p:spPr>
+          <a:xfrm>
+            <a:off x="54109" y="55518"/>
+            <a:ext cx="12082472" cy="6742445"/>
+          </a:xfrm>
+          <a:prstGeom prst="rect">
+            <a:avLst/>
+          </a:prstGeom>
+          <a:noFill/>
+        </p:spPr>
+        <p:style>
+          <a:lnRef idx="2">
+            <a:schemeClr val="accent1">
+              <a:shade val="15000"/>
+            </a:schemeClr>
+          </a:lnRef>
+          <a:fillRef idx="1">
+            <a:schemeClr val="accent1"/>
+          </a:fillRef>
+          <a:effectRef idx="0">
+            <a:schemeClr val="accent1"/>
+          </a:effectRef>
+          <a:fontRef idx="minor">
+            <a:schemeClr val="lt1"/>
+          </a:fontRef>
+        </p:style>
+        <p:txBody>
+          <a:bodyPr rtlCol="0" anchor="ctr"/>
+          <a:lstStyle/>
+          <a:p>
+            <a:pPr algn="ctr"/>
+            <a:endParaRPr lang="de-DE"/>
+          </a:p>
+        </p:txBody>
+      </p:sp>
     </p:spTree>
     <p:extLst>
       <p:ext uri="{BB962C8B-B14F-4D97-AF65-F5344CB8AC3E}">

</xml_diff>